<commit_message>
adding more lessons and context ;)
</commit_message>
<xml_diff>
--- a/pages/7DTA2/Units/Unit 2 - Game Programming/Presentations/L6_MakingOurGame.pptx
+++ b/pages/7DTA2/Units/Unit 2 - Game Programming/Presentations/L6_MakingOurGame.pptx
@@ -4,6 +4,9 @@
   <p:sldMasterIdLst>
     <p:sldMasterId id="2147483648" r:id="rId1"/>
   </p:sldMasterIdLst>
+  <p:notesMasterIdLst>
+    <p:notesMasterId r:id="rId17"/>
+  </p:notesMasterIdLst>
   <p:sldIdLst>
     <p:sldId id="256" r:id="rId2"/>
     <p:sldId id="257" r:id="rId3"/>
@@ -21,9 +24,6 @@
     <p:sldId id="269" r:id="rId15"/>
     <p:sldId id="270" r:id="rId16"/>
   </p:sldIdLst>
-  <p:notesMasterIdLst>
-    <p:notesMasterId r:id="rId17"/>
-  </p:notesMasterIdLst>
   <p:sldSz cx="12192000" cy="6858000"/>
   <p:notesSz cx="6858000" cy="12192000"/>
   <p:defaultTextStyle>
@@ -118,6 +118,11 @@
       </a:defRPr>
     </a:lvl9pPr>
   </p:defaultTextStyle>
+  <p:extLst>
+    <p:ext uri="{EFAFB233-063F-42B5-8137-9DF3F51BA10A}">
+      <p15:sldGuideLst xmlns:p15="http://schemas.microsoft.com/office/powerpoint/2012/main"/>
+    </p:ext>
+  </p:extLst>
 </p:presentation>
 </file>
 
@@ -143,234 +148,10 @@
           <a:chExt cx="0" cy="0"/>
         </a:xfrm>
       </p:grpSpPr>
-      <p:sp>
-        <p:nvSpPr>
-          <p:cNvPr id="2" name="Header Placeholder 1"/>
-          <p:cNvSpPr>
-            <a:spLocks noGrp="1"/>
-          </p:cNvSpPr>
-          <p:nvPr>
-            <p:ph type="hdr" sz="quarter"/>
-          </p:nvPr>
-        </p:nvSpPr>
-        <p:spPr>
-          <a:xfrm>
-            <a:off x="0" y="0"/>
-            <a:ext cx="2971800" cy="458788"/>
-          </a:xfrm>
-          <a:prstGeom prst="rect">
-            <a:avLst/>
-          </a:prstGeom>
-        </p:spPr>
-        <p:txBody>
-          <a:bodyPr vert="horz" lIns="91440" tIns="45720" rIns="91440" bIns="45720" rtlCol="0"/>
-          <a:lstStyle>
-            <a:lvl1pPr algn="l">
-              <a:defRPr sz="1200"/>
-            </a:lvl1pPr>
-          </a:lstStyle>
-          <a:p>
-            <a:endParaRPr lang="en-US"/>
-          </a:p>
-        </p:txBody>
-      </p:sp>
-      <p:sp>
-        <p:nvSpPr>
-          <p:cNvPr id="3" name="Date Placeholder 2"/>
-          <p:cNvSpPr>
-            <a:spLocks noGrp="1"/>
-          </p:cNvSpPr>
-          <p:nvPr>
-            <p:ph type="dt" idx="1"/>
-          </p:nvPr>
-        </p:nvSpPr>
-        <p:spPr>
-          <a:xfrm>
-            <a:off x="3884613" y="0"/>
-            <a:ext cx="2971800" cy="458788"/>
-          </a:xfrm>
-          <a:prstGeom prst="rect">
-            <a:avLst/>
-          </a:prstGeom>
-        </p:spPr>
-        <p:txBody>
-          <a:bodyPr vert="horz" lIns="91440" tIns="45720" rIns="91440" bIns="45720" rtlCol="0"/>
-          <a:lstStyle>
-            <a:lvl1pPr algn="r">
-              <a:defRPr sz="1200"/>
-            </a:lvl1pPr>
-          </a:lstStyle>
-          <a:p>
-            <a:fld id="{5282F153-3F37-0F45-9E97-73ACFA13230C}" type="datetimeFigureOut">
-              <a:rPr lang="en-US"/>
-              <a:t>7/23/19</a:t>
-            </a:fld>
-            <a:endParaRPr lang="en-US"/>
-          </a:p>
-        </p:txBody>
-      </p:sp>
-      <p:sp>
-        <p:nvSpPr>
-          <p:cNvPr id="4" name="Slide Image Placeholder 3"/>
-          <p:cNvSpPr>
-            <a:spLocks noGrp="1" noRot="1" noChangeAspect="1"/>
-          </p:cNvSpPr>
-          <p:nvPr>
-            <p:ph type="sldImg" idx="2"/>
-          </p:nvPr>
-        </p:nvSpPr>
-        <p:spPr>
-          <a:xfrm>
-            <a:off x="685800" y="1143000"/>
-            <a:ext cx="5486400" cy="3086100"/>
-          </a:xfrm>
-          <a:prstGeom prst="rect">
-            <a:avLst/>
-          </a:prstGeom>
-          <a:noFill/>
-          <a:ln w="12700">
-            <a:solidFill>
-              <a:prstClr val="black"/>
-            </a:solidFill>
-          </a:ln>
-        </p:spPr>
-        <p:txBody>
-          <a:bodyPr vert="horz" lIns="91440" tIns="45720" rIns="91440" bIns="45720" rtlCol="0" anchor="ctr"/>
-          <a:lstStyle/>
-          <a:p>
-            <a:endParaRPr lang="en-US"/>
-          </a:p>
-        </p:txBody>
-      </p:sp>
-      <p:sp>
-        <p:nvSpPr>
-          <p:cNvPr id="5" name="Notes Placeholder 4"/>
-          <p:cNvSpPr>
-            <a:spLocks noGrp="1"/>
-          </p:cNvSpPr>
-          <p:nvPr>
-            <p:ph type="body" sz="quarter" idx="3"/>
-          </p:nvPr>
-        </p:nvSpPr>
-        <p:spPr>
-          <a:xfrm>
-            <a:off x="685800" y="4400550"/>
-            <a:ext cx="5486400" cy="3600450"/>
-          </a:xfrm>
-          <a:prstGeom prst="rect">
-            <a:avLst/>
-          </a:prstGeom>
-        </p:spPr>
-        <p:txBody>
-          <a:bodyPr vert="horz" lIns="91440" tIns="45720" rIns="91440" bIns="45720" rtlCol="0"/>
-          <a:lstStyle/>
-          <a:p>
-            <a:pPr lvl="0"/>
-            <a:r>
-              <a:rPr lang="en-US"/>
-              <a:t>Click to edit Master text styles</a:t>
-            </a:r>
-          </a:p>
-          <a:p>
-            <a:pPr lvl="1"/>
-            <a:r>
-              <a:rPr lang="en-US"/>
-              <a:t>Second level</a:t>
-            </a:r>
-          </a:p>
-          <a:p>
-            <a:pPr lvl="2"/>
-            <a:r>
-              <a:rPr lang="en-US"/>
-              <a:t>Third level</a:t>
-            </a:r>
-          </a:p>
-          <a:p>
-            <a:pPr lvl="3"/>
-            <a:r>
-              <a:rPr lang="en-US"/>
-              <a:t>Fourth level</a:t>
-            </a:r>
-          </a:p>
-          <a:p>
-            <a:pPr lvl="4"/>
-            <a:r>
-              <a:rPr lang="en-US"/>
-              <a:t>Fifth level</a:t>
-            </a:r>
-          </a:p>
-        </p:txBody>
-      </p:sp>
-      <p:sp>
-        <p:nvSpPr>
-          <p:cNvPr id="6" name="Footer Placeholder 5"/>
-          <p:cNvSpPr>
-            <a:spLocks noGrp="1"/>
-          </p:cNvSpPr>
-          <p:nvPr>
-            <p:ph type="ftr" sz="quarter" idx="4"/>
-          </p:nvPr>
-        </p:nvSpPr>
-        <p:spPr>
-          <a:xfrm>
-            <a:off x="0" y="8685213"/>
-            <a:ext cx="2971800" cy="458787"/>
-          </a:xfrm>
-          <a:prstGeom prst="rect">
-            <a:avLst/>
-          </a:prstGeom>
-        </p:spPr>
-        <p:txBody>
-          <a:bodyPr vert="horz" lIns="91440" tIns="45720" rIns="91440" bIns="45720" rtlCol="0" anchor="b"/>
-          <a:lstStyle>
-            <a:lvl1pPr algn="l">
-              <a:defRPr sz="1200"/>
-            </a:lvl1pPr>
-          </a:lstStyle>
-          <a:p>
-            <a:endParaRPr lang="en-US"/>
-          </a:p>
-        </p:txBody>
-      </p:sp>
-      <p:sp>
-        <p:nvSpPr>
-          <p:cNvPr id="7" name="Slide Number Placeholder 6"/>
-          <p:cNvSpPr>
-            <a:spLocks noGrp="1"/>
-          </p:cNvSpPr>
-          <p:nvPr>
-            <p:ph type="sldNum" sz="quarter" idx="5"/>
-          </p:nvPr>
-        </p:nvSpPr>
-        <p:spPr>
-          <a:xfrm>
-            <a:off x="3884613" y="8685213"/>
-            <a:ext cx="2971800" cy="458787"/>
-          </a:xfrm>
-          <a:prstGeom prst="rect">
-            <a:avLst/>
-          </a:prstGeom>
-        </p:spPr>
-        <p:txBody>
-          <a:bodyPr vert="horz" lIns="91440" tIns="45720" rIns="91440" bIns="45720" rtlCol="0" anchor="b"/>
-          <a:lstStyle>
-            <a:lvl1pPr algn="r">
-              <a:defRPr sz="1200"/>
-            </a:lvl1pPr>
-          </a:lstStyle>
-          <a:p>
-            <a:fld id="{CE5E9CC1-C706-0F49-92D6-E571CC5EEA8F}" type="slidenum">
-              <a:rPr lang="en-US"/>
-              <a:t>‹#›</a:t>
-            </a:fld>
-            <a:endParaRPr lang="en-US"/>
-          </a:p>
-        </p:txBody>
-      </p:sp>
     </p:spTree>
     <p:extLst>
       <p:ext uri="{BB962C8B-B14F-4D97-AF65-F5344CB8AC3E}">
-        <p14:creationId xmlns:p14="http://schemas.microsoft.com/office/powerpoint/2010/main" val="1024086991"/>
+        <p14:creationId xmlns:p14="http://schemas.microsoft.com/office/powerpoint/2010/main" val="1724222779"/>
       </p:ext>
     </p:extLst>
   </p:cSld>
@@ -520,7 +301,6 @@
 This is a combined lesson: critique first, then the first half of CAT 1 build time. Be explicit at the transition that the assessment has started — students should know exactly when they cross that line.
 Have the CAT Task Sheet and rubric available. Students need their Lesson 2 sprite files and Lesson 5 project.</a:t>
             </a:r>
-            <a:endParaRPr lang="en-US" dirty="0"/>
           </a:p>
         </p:txBody>
       </p:sp>
@@ -609,7 +389,6 @@
               <a:t>4 minutes. Say the words 'the assessment starts now' out loud. Students should never be unclear about when they crossed into assessed work.
 Remind them the full rubric is on the CAT Task Sheet — today only two criteria are in play, on the next slide.</a:t>
             </a:r>
-            <a:endParaRPr lang="en-US" dirty="0"/>
           </a:p>
         </p:txBody>
       </p:sp>
@@ -698,7 +477,6 @@
               <a:t>4 minutes to brief. Run Checkpoint A conferences at roughly the 15-minute mark of studio time, moving desk to desk — 60 seconds each is enough.
 The self-check first is deliberate: it makes students look at their own work against criteria before you do, which is the habit the whole unit is building.</a:t>
             </a:r>
-            <a:endParaRPr lang="en-US" dirty="0"/>
           </a:p>
         </p:txBody>
       </p:sp>
@@ -787,7 +565,6 @@
               <a:t>3 minutes. Read the Developing column aloud — that's the standard expectation, and naming it prevents students aiming at Foundation by default.
 'Cohesive' in the Extending column means the art looks like it belongs to one game. Give a quick example: consistent colours and pixel size across every sprite.</a:t>
             </a:r>
-            <a:endParaRPr lang="en-US" dirty="0"/>
           </a:p>
         </p:txBody>
       </p:sp>
@@ -877,7 +654,6 @@
 Common time sink: students redrawing sprite art they already made in Lesson 2. Redirect them — the art exists, import it.
 Hold the line on 'don't start the modification'. Students who build it today arrive at Lesson 7 with nothing to do and often with a broken game.</a:t>
             </a:r>
-            <a:endParaRPr lang="en-US" dirty="0"/>
           </a:p>
         </p:txBody>
       </p:sp>
@@ -966,7 +742,6 @@
               <a:t>4 minutes. Question 3 is your planning data for Lesson 7 — read the answers and group students by what they still owe.
 Anyone who can't answer question 2 needs five minutes with you at the start of next lesson before they can begin building.</a:t>
             </a:r>
-            <a:endParaRPr lang="en-US" dirty="0"/>
           </a:p>
         </p:txBody>
       </p:sp>
@@ -1055,7 +830,6 @@
               <a:t>3 minutes. The homework framing matters: Lesson 7 has its own full workload, so anyone arriving with an unfinished reskin will be doing two lessons at once.
 Point students to the unit site Lesson 6 section for the criteria and the rubric extract if they need them at home.</a:t>
             </a:r>
-            <a:endParaRPr lang="en-US" dirty="0"/>
           </a:p>
         </p:txBody>
       </p:sp>
@@ -1144,7 +918,6 @@
               <a:t>8 minutes, unplugged. The word ban is the entire mechanism — enforce it cheerfully and make students restate when they slip.
 Collect two or three examples and push each one: 'why did that feel unfair?' until you get something specific. Those live examples make the four criteria on slide 4 feel like names for things they already noticed.</a:t>
             </a:r>
-            <a:endParaRPr lang="en-US" dirty="0"/>
           </a:p>
         </p:txBody>
       </p:sp>
@@ -1233,7 +1006,6 @@
               <a:t>4 minutes. Be clear that the criteria cards cover both halves — the first line of each is the critique work, the second is the build.
 Students copy the objective and tick their target tier in workbook Section 1.</a:t>
             </a:r>
-            <a:endParaRPr lang="en-US" dirty="0"/>
           </a:p>
         </p:txBody>
       </p:sp>
@@ -1322,7 +1094,6 @@
               <a:t>8 minutes. Tie each criterion back to a warm-up example from the board — 'that unfair jump you mentioned, that's difficulty'.
 Feedback is the one Year 7 students most often miss in their own games: no sound, no score change, no visual signal when something important happens. Flag it now, because it's the easiest weakness for them to fix later today.</a:t>
             </a:r>
-            <a:endParaRPr lang="en-US" dirty="0"/>
           </a:p>
         </p:txBody>
       </p:sp>
@@ -1411,7 +1182,6 @@
               <a:t>6 minutes. Model one live: take a weak statement from the warm-up and rebuild it through the frame with the class.
 The frame is scaffolding, not a rule — Extending students should move past it. Foundation students should use it word for word.</a:t>
             </a:r>
-            <a:endParaRPr lang="en-US" dirty="0"/>
           </a:p>
         </p:txBody>
       </p:sp>
@@ -1501,7 +1271,6 @@
 The watching partner is not optional: noticing is easier from outside the controls. Swap at the halfway mark.
 Circulate and push back on the first vague comment you see in each pair. One correction early saves ten later.</a:t>
             </a:r>
-            <a:endParaRPr lang="en-US" dirty="0"/>
           </a:p>
         </p:txBody>
       </p:sp>
@@ -1591,7 +1360,6 @@
 Stop students who defend their game while their partner is playing. Silence is the task.
 By the end of this task every student needs a written proposed fix — it's the input to next lesson's modification work.</a:t>
             </a:r>
-            <a:endParaRPr lang="en-US" dirty="0"/>
           </a:p>
         </p:txBody>
       </p:sp>
@@ -1680,7 +1448,6 @@
               <a:t>4 minutes. Some students will need talking down from something enormous — do it as scoping, never as 'you can't'.
 Useful question for an over-ambitious plan: 'which single part of that would make the biggest difference on its own?' That usually finds the buildable version inside the big idea.</a:t>
             </a:r>
-            <a:endParaRPr lang="en-US" dirty="0"/>
           </a:p>
         </p:txBody>
       </p:sp>
@@ -1769,7 +1536,6 @@
               <a:t>5 minutes including settling. Use this window to sort out missing files — a student without sprite art needs a plan before studio time starts, not halfway through it.
 This break is deliberately placed at the seam between the two halves of the lesson. It marks the transition into assessed work.</a:t>
             </a:r>
-            <a:endParaRPr lang="en-US" dirty="0"/>
           </a:p>
         </p:txBody>
       </p:sp>
@@ -1842,6 +1608,11 @@
 <file path=ppt/slideMasters/slideMaster1.xml><?xml version="1.0" encoding="utf-8"?>
 <p:sldMaster xmlns:a="http://schemas.openxmlformats.org/drawingml/2006/main" xmlns:r="http://schemas.openxmlformats.org/officeDocument/2006/relationships" xmlns:p="http://schemas.openxmlformats.org/presentationml/2006/main">
   <p:cSld>
+    <p:bg>
+      <p:bgRef idx="1001">
+        <a:schemeClr val="bg1"/>
+      </p:bgRef>
+    </p:bg>
     <p:spTree>
       <p:nvGrpSpPr>
         <p:cNvPr id="1" name=""/>
@@ -2124,6 +1895,7 @@
         <a:solidFill>
           <a:srgbClr val="FFFFFF"/>
         </a:solidFill>
+        <a:effectLst/>
       </p:bgPr>
     </p:bg>
     <p:spTree>
@@ -2161,11 +1933,11 @@
           <a:bodyPr wrap="square" lIns="0" tIns="0" rIns="0" bIns="0" rtlCol="0" anchor="ctr"/>
           <a:lstStyle/>
           <a:p>
-            <a:pPr indent="0" marL="0">
-              <a:buNone/>
-            </a:pPr>
-            <a:r>
-              <a:rPr lang="en-US" sz="1400" b="1" spc="180" kern="0" dirty="0">
+            <a:pPr marL="0" indent="0">
+              <a:buNone/>
+            </a:pPr>
+            <a:r>
+              <a:rPr lang="en-US" sz="1400" b="1" kern="0" spc="180" dirty="0">
                 <a:solidFill>
                   <a:srgbClr val="4361EE"/>
                 </a:solidFill>
@@ -2200,7 +1972,7 @@
           <a:bodyPr wrap="square" lIns="0" tIns="0" rIns="0" bIns="0" rtlCol="0" anchor="ctr"/>
           <a:lstStyle/>
           <a:p>
-            <a:pPr indent="0" marL="0">
+            <a:pPr marL="0" indent="0">
               <a:buNone/>
             </a:pPr>
             <a:r>
@@ -2239,7 +2011,7 @@
           <a:bodyPr wrap="square" lIns="0" tIns="0" rIns="0" bIns="0" rtlCol="0" anchor="ctr"/>
           <a:lstStyle/>
           <a:p>
-            <a:pPr indent="0" marL="0">
+            <a:pPr marL="0" indent="0">
               <a:buNone/>
             </a:pPr>
             <a:r>
@@ -2254,72 +2026,6 @@
               <a:t>First we learn to judge a game properly — including our own. Then assessed build time begins.</a:t>
             </a:r>
             <a:endParaRPr lang="en-US" sz="2000" dirty="0"/>
-          </a:p>
-        </p:txBody>
-      </p:sp>
-      <p:sp>
-        <p:nvSpPr>
-          <p:cNvPr id="5" name="Shape 3"/>
-          <p:cNvSpPr/>
-          <p:nvPr/>
-        </p:nvSpPr>
-        <p:spPr>
-          <a:xfrm>
-            <a:off x="640080" y="4937760"/>
-            <a:ext cx="5852160" cy="502920"/>
-          </a:xfrm>
-          <a:prstGeom prst="roundRect">
-            <a:avLst>
-              <a:gd name="adj" fmla="val 12727"/>
-            </a:avLst>
-          </a:prstGeom>
-          <a:solidFill>
-            <a:srgbClr val="FDECEC"/>
-          </a:solidFill>
-          <a:ln w="12700">
-            <a:solidFill>
-              <a:srgbClr val="EF4444"/>
-            </a:solidFill>
-            <a:prstDash val="solid"/>
-          </a:ln>
-        </p:spPr>
-      </p:sp>
-      <p:sp>
-        <p:nvSpPr>
-          <p:cNvPr id="6" name="Text 4"/>
-          <p:cNvSpPr/>
-          <p:nvPr/>
-        </p:nvSpPr>
-        <p:spPr>
-          <a:xfrm>
-            <a:off x="640080" y="4937760"/>
-            <a:ext cx="5852160" cy="502920"/>
-          </a:xfrm>
-          <a:prstGeom prst="rect">
-            <a:avLst/>
-          </a:prstGeom>
-          <a:noFill/>
-          <a:ln/>
-        </p:spPr>
-        <p:txBody>
-          <a:bodyPr wrap="square" lIns="0" tIns="0" rIns="0" bIns="0" rtlCol="0" anchor="ctr"/>
-          <a:lstStyle/>
-          <a:p>
-            <a:pPr algn="ctr" indent="0" marL="0">
-              <a:buNone/>
-            </a:pPr>
-            <a:r>
-              <a:rPr lang="en-US" sz="1700" b="1" dirty="0">
-                <a:solidFill>
-                  <a:srgbClr val="EF4444"/>
-                </a:solidFill>
-                <a:latin typeface="Calibri" pitchFamily="34" charset="0"/>
-                <a:ea typeface="Calibri" pitchFamily="34" charset="-122"/>
-                <a:cs typeface="Calibri" pitchFamily="34" charset="-120"/>
-              </a:rPr>
-              <a:t>The second half of today is CAT 1 — assessed</a:t>
-            </a:r>
-            <a:endParaRPr lang="en-US" sz="1700" dirty="0"/>
           </a:p>
         </p:txBody>
       </p:sp>
@@ -2349,6 +2055,13 @@
             <a:prstDash val="solid"/>
           </a:ln>
         </p:spPr>
+        <p:txBody>
+          <a:bodyPr/>
+          <a:lstStyle/>
+          <a:p>
+            <a:endParaRPr lang="en-AU"/>
+          </a:p>
+        </p:txBody>
       </p:sp>
       <p:sp>
         <p:nvSpPr>
@@ -2371,11 +2084,11 @@
           <a:bodyPr wrap="square" lIns="0" tIns="0" rIns="0" bIns="0" rtlCol="0" anchor="ctr"/>
           <a:lstStyle/>
           <a:p>
-            <a:pPr algn="ctr" indent="0" marL="0">
-              <a:buNone/>
-            </a:pPr>
-            <a:r>
-              <a:rPr lang="en-US" sz="1100" b="1" spc="100" kern="0" dirty="0">
+            <a:pPr marL="0" indent="0" algn="ctr">
+              <a:buNone/>
+            </a:pPr>
+            <a:r>
+              <a:rPr lang="en-US" sz="1100" b="1" kern="0" spc="100" dirty="0">
                 <a:solidFill>
                   <a:srgbClr val="EF4444"/>
                 </a:solidFill>
@@ -2405,6 +2118,7 @@
         <a:solidFill>
           <a:srgbClr val="FFFFFF"/>
         </a:solidFill>
+        <a:effectLst/>
       </p:bgPr>
     </p:bg>
     <p:spTree>
@@ -2442,11 +2156,11 @@
           <a:bodyPr wrap="square" lIns="0" tIns="0" rIns="0" bIns="0" rtlCol="0" anchor="ctr"/>
           <a:lstStyle/>
           <a:p>
-            <a:pPr indent="0" marL="0">
-              <a:buNone/>
-            </a:pPr>
-            <a:r>
-              <a:rPr lang="en-US" sz="1200" b="1" spc="160" kern="0" dirty="0">
+            <a:pPr marL="0" indent="0">
+              <a:buNone/>
+            </a:pPr>
+            <a:r>
+              <a:rPr lang="en-US" sz="1200" b="1" kern="0" spc="160" dirty="0">
                 <a:solidFill>
                   <a:srgbClr val="6B7280"/>
                 </a:solidFill>
@@ -2481,7 +2195,7 @@
           <a:bodyPr wrap="square" lIns="0" tIns="0" rIns="0" bIns="0" rtlCol="0" anchor="t"/>
           <a:lstStyle/>
           <a:p>
-            <a:pPr indent="0" marL="0">
+            <a:pPr marL="0" indent="0">
               <a:buNone/>
             </a:pPr>
             <a:r>
@@ -2525,6 +2239,13 @@
             <a:prstDash val="solid"/>
           </a:ln>
         </p:spPr>
+        <p:txBody>
+          <a:bodyPr/>
+          <a:lstStyle/>
+          <a:p>
+            <a:endParaRPr lang="en-AU"/>
+          </a:p>
+        </p:txBody>
       </p:sp>
       <p:sp>
         <p:nvSpPr>
@@ -2547,11 +2268,11 @@
           <a:bodyPr wrap="square" lIns="0" tIns="0" rIns="0" bIns="0" rtlCol="0" anchor="ctr"/>
           <a:lstStyle/>
           <a:p>
-            <a:pPr algn="ctr" indent="0" marL="0">
-              <a:buNone/>
-            </a:pPr>
-            <a:r>
-              <a:rPr lang="en-US" sz="1200" b="1" spc="120" kern="0" dirty="0">
+            <a:pPr marL="0" indent="0" algn="ctr">
+              <a:buNone/>
+            </a:pPr>
+            <a:r>
+              <a:rPr lang="en-US" sz="1200" b="1" kern="0" spc="120" dirty="0">
                 <a:solidFill>
                   <a:srgbClr val="FFFFFF"/>
                 </a:solidFill>
@@ -2591,6 +2312,13 @@
             <a:prstDash val="solid"/>
           </a:ln>
         </p:spPr>
+        <p:txBody>
+          <a:bodyPr/>
+          <a:lstStyle/>
+          <a:p>
+            <a:endParaRPr lang="en-AU"/>
+          </a:p>
+        </p:txBody>
       </p:sp>
       <p:sp>
         <p:nvSpPr>
@@ -2613,11 +2341,11 @@
           <a:bodyPr wrap="square" lIns="0" tIns="0" rIns="0" bIns="0" rtlCol="0" anchor="ctr"/>
           <a:lstStyle/>
           <a:p>
-            <a:pPr algn="ctr" indent="0" marL="0">
-              <a:buNone/>
-            </a:pPr>
-            <a:r>
-              <a:rPr lang="en-US" sz="1100" b="1" spc="100" kern="0" dirty="0">
+            <a:pPr marL="0" indent="0" algn="ctr">
+              <a:buNone/>
+            </a:pPr>
+            <a:r>
+              <a:rPr lang="en-US" sz="1100" b="1" kern="0" spc="100" dirty="0">
                 <a:solidFill>
                   <a:srgbClr val="10B981"/>
                 </a:solidFill>
@@ -2657,13 +2385,20 @@
             <a:prstDash val="solid"/>
           </a:ln>
           <a:effectLst>
-            <a:outerShdw sx="100000" sy="100000" kx="0" ky="0" algn="bl" rotWithShape="0" blurRad="76200" dist="12700" dir="5400000">
+            <a:outerShdw blurRad="76200" dist="12700" dir="5400000" algn="bl" rotWithShape="0">
               <a:srgbClr val="9AA4B2">
                 <a:alpha val="18000"/>
               </a:srgbClr>
             </a:outerShdw>
           </a:effectLst>
         </p:spPr>
+        <p:txBody>
+          <a:bodyPr/>
+          <a:lstStyle/>
+          <a:p>
+            <a:endParaRPr lang="en-AU"/>
+          </a:p>
+        </p:txBody>
       </p:sp>
       <p:sp>
         <p:nvSpPr>
@@ -2686,7 +2421,7 @@
           <a:bodyPr wrap="square" lIns="0" tIns="0" rIns="0" bIns="0" rtlCol="0" anchor="ctr"/>
           <a:lstStyle/>
           <a:p>
-            <a:pPr indent="0" marL="0">
+            <a:pPr marL="0" indent="0">
               <a:lnSpc>
                 <a:spcPts val="2600"/>
               </a:lnSpc>
@@ -2728,7 +2463,7 @@
           <a:bodyPr wrap="square" lIns="0" tIns="0" rIns="0" bIns="0" rtlCol="0" anchor="ctr"/>
           <a:lstStyle/>
           <a:p>
-            <a:pPr indent="0" marL="0">
+            <a:pPr marL="0" indent="0">
               <a:buNone/>
             </a:pPr>
             <a:r>
@@ -2772,13 +2507,20 @@
             <a:prstDash val="solid"/>
           </a:ln>
           <a:effectLst>
-            <a:outerShdw sx="100000" sy="100000" kx="0" ky="0" algn="bl" rotWithShape="0" blurRad="76200" dist="12700" dir="5400000">
+            <a:outerShdw blurRad="76200" dist="12700" dir="5400000" algn="bl" rotWithShape="0">
               <a:srgbClr val="9AA4B2">
                 <a:alpha val="18000"/>
               </a:srgbClr>
             </a:outerShdw>
           </a:effectLst>
         </p:spPr>
+        <p:txBody>
+          <a:bodyPr/>
+          <a:lstStyle/>
+          <a:p>
+            <a:endParaRPr lang="en-AU"/>
+          </a:p>
+        </p:txBody>
       </p:sp>
       <p:sp>
         <p:nvSpPr>
@@ -2801,7 +2543,7 @@
           <a:bodyPr wrap="square" lIns="0" tIns="0" rIns="0" bIns="0" rtlCol="0" anchor="ctr"/>
           <a:lstStyle/>
           <a:p>
-            <a:pPr indent="0" marL="0">
+            <a:pPr marL="0" indent="0">
               <a:buNone/>
             </a:pPr>
             <a:r>
@@ -2840,7 +2582,7 @@
           <a:bodyPr wrap="square" lIns="0" tIns="0" rIns="0" bIns="0" rtlCol="0" anchor="ctr"/>
           <a:lstStyle/>
           <a:p>
-            <a:pPr indent="0" marL="0">
+            <a:pPr marL="0" indent="0">
               <a:lnSpc>
                 <a:spcPts val="2100"/>
               </a:lnSpc>
@@ -2887,13 +2629,20 @@
             <a:prstDash val="solid"/>
           </a:ln>
           <a:effectLst>
-            <a:outerShdw sx="100000" sy="100000" kx="0" ky="0" algn="bl" rotWithShape="0" blurRad="76200" dist="12700" dir="5400000">
+            <a:outerShdw blurRad="76200" dist="12700" dir="5400000" algn="bl" rotWithShape="0">
               <a:srgbClr val="9AA4B2">
                 <a:alpha val="18000"/>
               </a:srgbClr>
             </a:outerShdw>
           </a:effectLst>
         </p:spPr>
+        <p:txBody>
+          <a:bodyPr/>
+          <a:lstStyle/>
+          <a:p>
+            <a:endParaRPr lang="en-AU"/>
+          </a:p>
+        </p:txBody>
       </p:sp>
       <p:sp>
         <p:nvSpPr>
@@ -2916,7 +2665,7 @@
           <a:bodyPr wrap="square" lIns="0" tIns="0" rIns="0" bIns="0" rtlCol="0" anchor="ctr"/>
           <a:lstStyle/>
           <a:p>
-            <a:pPr indent="0" marL="0">
+            <a:pPr marL="0" indent="0">
               <a:buNone/>
             </a:pPr>
             <a:r>
@@ -2955,7 +2704,7 @@
           <a:bodyPr wrap="square" lIns="0" tIns="0" rIns="0" bIns="0" rtlCol="0" anchor="ctr"/>
           <a:lstStyle/>
           <a:p>
-            <a:pPr indent="0" marL="0">
+            <a:pPr marL="0" indent="0">
               <a:lnSpc>
                 <a:spcPts val="2100"/>
               </a:lnSpc>
@@ -3002,13 +2751,20 @@
             <a:prstDash val="solid"/>
           </a:ln>
           <a:effectLst>
-            <a:outerShdw sx="100000" sy="100000" kx="0" ky="0" algn="bl" rotWithShape="0" blurRad="76200" dist="12700" dir="5400000">
+            <a:outerShdw blurRad="76200" dist="12700" dir="5400000" algn="bl" rotWithShape="0">
               <a:srgbClr val="9AA4B2">
                 <a:alpha val="18000"/>
               </a:srgbClr>
             </a:outerShdw>
           </a:effectLst>
         </p:spPr>
+        <p:txBody>
+          <a:bodyPr/>
+          <a:lstStyle/>
+          <a:p>
+            <a:endParaRPr lang="en-AU"/>
+          </a:p>
+        </p:txBody>
       </p:sp>
       <p:sp>
         <p:nvSpPr>
@@ -3031,7 +2787,7 @@
           <a:bodyPr wrap="square" lIns="0" tIns="0" rIns="0" bIns="0" rtlCol="0" anchor="ctr"/>
           <a:lstStyle/>
           <a:p>
-            <a:pPr indent="0" marL="0">
+            <a:pPr marL="0" indent="0">
               <a:buNone/>
             </a:pPr>
             <a:r>
@@ -3070,7 +2826,7 @@
           <a:bodyPr wrap="square" lIns="0" tIns="0" rIns="0" bIns="0" rtlCol="0" anchor="ctr"/>
           <a:lstStyle/>
           <a:p>
-            <a:pPr indent="0" marL="0">
+            <a:pPr marL="0" indent="0">
               <a:lnSpc>
                 <a:spcPts val="2100"/>
               </a:lnSpc>
@@ -3112,7 +2868,7 @@
           <a:bodyPr wrap="square" lIns="0" tIns="0" rIns="0" bIns="0" rtlCol="0" anchor="ctr"/>
           <a:lstStyle/>
           <a:p>
-            <a:pPr indent="0" marL="0">
+            <a:pPr marL="0" indent="0">
               <a:buNone/>
             </a:pPr>
             <a:r>
@@ -3146,6 +2902,7 @@
         <a:solidFill>
           <a:srgbClr val="FFFFFF"/>
         </a:solidFill>
+        <a:effectLst/>
       </p:bgPr>
     </p:bg>
     <p:spTree>
@@ -3183,11 +2940,11 @@
           <a:bodyPr wrap="square" lIns="0" tIns="0" rIns="0" bIns="0" rtlCol="0" anchor="ctr"/>
           <a:lstStyle/>
           <a:p>
-            <a:pPr indent="0" marL="0">
-              <a:buNone/>
-            </a:pPr>
-            <a:r>
-              <a:rPr lang="en-US" sz="1200" b="1" spc="160" kern="0" dirty="0">
+            <a:pPr marL="0" indent="0">
+              <a:buNone/>
+            </a:pPr>
+            <a:r>
+              <a:rPr lang="en-US" sz="1200" b="1" kern="0" spc="160" dirty="0">
                 <a:solidFill>
                   <a:srgbClr val="6B7280"/>
                 </a:solidFill>
@@ -3222,7 +2979,7 @@
           <a:bodyPr wrap="square" lIns="0" tIns="0" rIns="0" bIns="0" rtlCol="0" anchor="t"/>
           <a:lstStyle/>
           <a:p>
-            <a:pPr indent="0" marL="0">
+            <a:pPr marL="0" indent="0">
               <a:buNone/>
             </a:pPr>
             <a:r>
@@ -3266,6 +3023,13 @@
             <a:prstDash val="solid"/>
           </a:ln>
         </p:spPr>
+        <p:txBody>
+          <a:bodyPr/>
+          <a:lstStyle/>
+          <a:p>
+            <a:endParaRPr lang="en-AU"/>
+          </a:p>
+        </p:txBody>
       </p:sp>
       <p:sp>
         <p:nvSpPr>
@@ -3288,11 +3052,11 @@
           <a:bodyPr wrap="square" lIns="0" tIns="0" rIns="0" bIns="0" rtlCol="0" anchor="ctr"/>
           <a:lstStyle/>
           <a:p>
-            <a:pPr algn="ctr" indent="0" marL="0">
-              <a:buNone/>
-            </a:pPr>
-            <a:r>
-              <a:rPr lang="en-US" sz="1200" b="1" spc="120" kern="0" dirty="0">
+            <a:pPr marL="0" indent="0" algn="ctr">
+              <a:buNone/>
+            </a:pPr>
+            <a:r>
+              <a:rPr lang="en-US" sz="1200" b="1" kern="0" spc="120" dirty="0">
                 <a:solidFill>
                   <a:srgbClr val="FFFFFF"/>
                 </a:solidFill>
@@ -3332,6 +3096,13 @@
             <a:prstDash val="solid"/>
           </a:ln>
         </p:spPr>
+        <p:txBody>
+          <a:bodyPr/>
+          <a:lstStyle/>
+          <a:p>
+            <a:endParaRPr lang="en-AU"/>
+          </a:p>
+        </p:txBody>
       </p:sp>
       <p:sp>
         <p:nvSpPr>
@@ -3354,11 +3125,11 @@
           <a:bodyPr wrap="square" lIns="0" tIns="0" rIns="0" bIns="0" rtlCol="0" anchor="ctr"/>
           <a:lstStyle/>
           <a:p>
-            <a:pPr algn="ctr" indent="0" marL="0">
-              <a:buNone/>
-            </a:pPr>
-            <a:r>
-              <a:rPr lang="en-US" sz="1100" b="1" spc="100" kern="0" dirty="0">
+            <a:pPr marL="0" indent="0" algn="ctr">
+              <a:buNone/>
+            </a:pPr>
+            <a:r>
+              <a:rPr lang="en-US" sz="1100" b="1" kern="0" spc="100" dirty="0">
                 <a:solidFill>
                   <a:srgbClr val="10B981"/>
                 </a:solidFill>
@@ -3393,7 +3164,7 @@
           <a:bodyPr wrap="square" lIns="0" tIns="0" rIns="0" bIns="0" rtlCol="0" anchor="ctr"/>
           <a:lstStyle/>
           <a:p>
-            <a:pPr indent="0" marL="0">
+            <a:pPr marL="0" indent="0">
               <a:buNone/>
             </a:pPr>
             <a:r>
@@ -3437,13 +3208,20 @@
             <a:prstDash val="solid"/>
           </a:ln>
           <a:effectLst>
-            <a:outerShdw sx="100000" sy="100000" kx="0" ky="0" algn="bl" rotWithShape="0" blurRad="76200" dist="12700" dir="5400000">
+            <a:outerShdw blurRad="76200" dist="12700" dir="5400000" algn="bl" rotWithShape="0">
               <a:srgbClr val="9AA4B2">
                 <a:alpha val="18000"/>
               </a:srgbClr>
             </a:outerShdw>
           </a:effectLst>
         </p:spPr>
+        <p:txBody>
+          <a:bodyPr/>
+          <a:lstStyle/>
+          <a:p>
+            <a:endParaRPr lang="en-AU"/>
+          </a:p>
+        </p:txBody>
       </p:sp>
       <p:sp>
         <p:nvSpPr>
@@ -3466,7 +3244,7 @@
           <a:bodyPr wrap="square" lIns="0" tIns="0" rIns="0" bIns="0" rtlCol="0" anchor="ctr"/>
           <a:lstStyle/>
           <a:p>
-            <a:pPr indent="0" marL="0">
+            <a:pPr marL="0" indent="0">
               <a:buNone/>
             </a:pPr>
             <a:r>
@@ -3505,7 +3283,7 @@
           <a:bodyPr wrap="square" lIns="0" tIns="0" rIns="0" bIns="0" rtlCol="0" anchor="ctr"/>
           <a:lstStyle/>
           <a:p>
-            <a:pPr indent="0" marL="0">
+            <a:pPr marL="0" indent="0">
               <a:spcAft>
                 <a:spcPts val="600"/>
               </a:spcAft>
@@ -3525,7 +3303,7 @@
             <a:endParaRPr lang="en-US" sz="1700" dirty="0"/>
           </a:p>
           <a:p>
-            <a:pPr indent="0" marL="0">
+            <a:pPr marL="0" indent="0">
               <a:spcAft>
                 <a:spcPts val="600"/>
               </a:spcAft>
@@ -3614,13 +3392,20 @@
             <a:prstDash val="solid"/>
           </a:ln>
           <a:effectLst>
-            <a:outerShdw sx="100000" sy="100000" kx="0" ky="0" algn="bl" rotWithShape="0" blurRad="76200" dist="12700" dir="5400000">
+            <a:outerShdw blurRad="76200" dist="12700" dir="5400000" algn="bl" rotWithShape="0">
               <a:srgbClr val="9AA4B2">
                 <a:alpha val="18000"/>
               </a:srgbClr>
             </a:outerShdw>
           </a:effectLst>
         </p:spPr>
+        <p:txBody>
+          <a:bodyPr/>
+          <a:lstStyle/>
+          <a:p>
+            <a:endParaRPr lang="en-AU"/>
+          </a:p>
+        </p:txBody>
       </p:sp>
       <p:sp>
         <p:nvSpPr>
@@ -3643,7 +3428,7 @@
           <a:bodyPr wrap="square" lIns="0" tIns="0" rIns="0" bIns="0" rtlCol="0" anchor="ctr"/>
           <a:lstStyle/>
           <a:p>
-            <a:pPr indent="0" marL="0">
+            <a:pPr marL="0" indent="0">
               <a:buNone/>
             </a:pPr>
             <a:r>
@@ -3682,7 +3467,7 @@
           <a:bodyPr wrap="square" lIns="0" tIns="0" rIns="0" bIns="0" rtlCol="0" anchor="ctr"/>
           <a:lstStyle/>
           <a:p>
-            <a:pPr indent="0" marL="0">
+            <a:pPr marL="0" indent="0">
               <a:spcAft>
                 <a:spcPts val="600"/>
               </a:spcAft>
@@ -3702,7 +3487,7 @@
             <a:endParaRPr lang="en-US" sz="1700" dirty="0"/>
           </a:p>
           <a:p>
-            <a:pPr indent="0" marL="0">
+            <a:pPr marL="0" indent="0">
               <a:spcAft>
                 <a:spcPts val="600"/>
               </a:spcAft>
@@ -3786,7 +3571,7 @@
           <a:bodyPr wrap="square" lIns="0" tIns="0" rIns="0" bIns="0" rtlCol="0" anchor="ctr"/>
           <a:lstStyle/>
           <a:p>
-            <a:pPr indent="0" marL="0">
+            <a:pPr marL="0" indent="0">
               <a:buNone/>
             </a:pPr>
             <a:r>
@@ -3820,6 +3605,7 @@
         <a:solidFill>
           <a:srgbClr val="FFFFFF"/>
         </a:solidFill>
+        <a:effectLst/>
       </p:bgPr>
     </p:bg>
     <p:spTree>
@@ -3857,11 +3643,11 @@
           <a:bodyPr wrap="square" lIns="0" tIns="0" rIns="0" bIns="0" rtlCol="0" anchor="ctr"/>
           <a:lstStyle/>
           <a:p>
-            <a:pPr indent="0" marL="0">
-              <a:buNone/>
-            </a:pPr>
-            <a:r>
-              <a:rPr lang="en-US" sz="1200" b="1" spc="160" kern="0" dirty="0">
+            <a:pPr marL="0" indent="0">
+              <a:buNone/>
+            </a:pPr>
+            <a:r>
+              <a:rPr lang="en-US" sz="1200" b="1" kern="0" spc="160" dirty="0">
                 <a:solidFill>
                   <a:srgbClr val="6B7280"/>
                 </a:solidFill>
@@ -3896,7 +3682,7 @@
           <a:bodyPr wrap="square" lIns="0" tIns="0" rIns="0" bIns="0" rtlCol="0" anchor="t"/>
           <a:lstStyle/>
           <a:p>
-            <a:pPr indent="0" marL="0">
+            <a:pPr marL="0" indent="0">
               <a:buNone/>
             </a:pPr>
             <a:r>
@@ -3940,6 +3726,13 @@
             <a:prstDash val="solid"/>
           </a:ln>
         </p:spPr>
+        <p:txBody>
+          <a:bodyPr/>
+          <a:lstStyle/>
+          <a:p>
+            <a:endParaRPr lang="en-AU"/>
+          </a:p>
+        </p:txBody>
       </p:sp>
       <p:sp>
         <p:nvSpPr>
@@ -3962,11 +3755,11 @@
           <a:bodyPr wrap="square" lIns="0" tIns="0" rIns="0" bIns="0" rtlCol="0" anchor="ctr"/>
           <a:lstStyle/>
           <a:p>
-            <a:pPr algn="ctr" indent="0" marL="0">
-              <a:buNone/>
-            </a:pPr>
-            <a:r>
-              <a:rPr lang="en-US" sz="1200" b="1" spc="120" kern="0" dirty="0">
+            <a:pPr marL="0" indent="0" algn="ctr">
+              <a:buNone/>
+            </a:pPr>
+            <a:r>
+              <a:rPr lang="en-US" sz="1200" b="1" kern="0" spc="120" dirty="0">
                 <a:solidFill>
                   <a:srgbClr val="FFFFFF"/>
                 </a:solidFill>
@@ -4006,6 +3799,13 @@
             <a:prstDash val="solid"/>
           </a:ln>
         </p:spPr>
+        <p:txBody>
+          <a:bodyPr/>
+          <a:lstStyle/>
+          <a:p>
+            <a:endParaRPr lang="en-AU"/>
+          </a:p>
+        </p:txBody>
       </p:sp>
       <p:sp>
         <p:nvSpPr>
@@ -4028,11 +3828,11 @@
           <a:bodyPr wrap="square" lIns="0" tIns="0" rIns="0" bIns="0" rtlCol="0" anchor="ctr"/>
           <a:lstStyle/>
           <a:p>
-            <a:pPr algn="ctr" indent="0" marL="0">
-              <a:buNone/>
-            </a:pPr>
-            <a:r>
-              <a:rPr lang="en-US" sz="1100" b="1" spc="100" kern="0" dirty="0">
+            <a:pPr marL="0" indent="0" algn="ctr">
+              <a:buNone/>
+            </a:pPr>
+            <a:r>
+              <a:rPr lang="en-US" sz="1100" b="1" kern="0" spc="100" dirty="0">
                 <a:solidFill>
                   <a:srgbClr val="10B981"/>
                 </a:solidFill>
@@ -4062,17 +3862,41 @@
         </p:nvGraphicFramePr>
         <p:xfrm>
           <a:off x="640080" y="1554480"/>
-          <a:ext cx="10881360" cy="914400"/>
+          <a:ext cx="10881360" cy="3154680"/>
         </p:xfrm>
         <a:graphic>
           <a:graphicData uri="http://schemas.openxmlformats.org/drawingml/2006/table">
             <a:tbl>
               <a:tblPr/>
               <a:tblGrid>
-                <a:gridCol w="2743200"/>
-                <a:gridCol w="2606040"/>
-                <a:gridCol w="2743200"/>
-                <a:gridCol w="2788920"/>
+                <a:gridCol w="2743200">
+                  <a:extLst>
+                    <a:ext uri="{9D8B030D-6E8A-4147-A177-3AD203B41FA5}">
+                      <a16:colId xmlns:a16="http://schemas.microsoft.com/office/drawing/2014/main" val="20000"/>
+                    </a:ext>
+                  </a:extLst>
+                </a:gridCol>
+                <a:gridCol w="2606040">
+                  <a:extLst>
+                    <a:ext uri="{9D8B030D-6E8A-4147-A177-3AD203B41FA5}">
+                      <a16:colId xmlns:a16="http://schemas.microsoft.com/office/drawing/2014/main" val="20001"/>
+                    </a:ext>
+                  </a:extLst>
+                </a:gridCol>
+                <a:gridCol w="2743200">
+                  <a:extLst>
+                    <a:ext uri="{9D8B030D-6E8A-4147-A177-3AD203B41FA5}">
+                      <a16:colId xmlns:a16="http://schemas.microsoft.com/office/drawing/2014/main" val="20002"/>
+                    </a:ext>
+                  </a:extLst>
+                </a:gridCol>
+                <a:gridCol w="2788920">
+                  <a:extLst>
+                    <a:ext uri="{9D8B030D-6E8A-4147-A177-3AD203B41FA5}">
+                      <a16:colId xmlns:a16="http://schemas.microsoft.com/office/drawing/2014/main" val="20003"/>
+                    </a:ext>
+                  </a:extLst>
+                </a:gridCol>
               </a:tblGrid>
               <a:tr h="1051560">
                 <a:tc>
@@ -4080,7 +3904,7 @@
                     <a:bodyPr/>
                     <a:lstStyle/>
                     <a:p>
-                      <a:pPr indent="0" marL="0">
+                      <a:pPr marL="0" indent="0">
                         <a:buNone/>
                       </a:pPr>
                       <a:r>
@@ -4101,7 +3925,7 @@
                       </a:endParaRPr>
                     </a:p>
                   </a:txBody>
-                  <a:tcPr marL="91440" marR="91440" marT="45720" marB="45720" anchor="ctr">
+                  <a:tcPr anchor="ctr">
                     <a:lnL w="12700" cap="flat" cmpd="sng" algn="ctr">
                       <a:solidFill>
                         <a:srgbClr val="D9DEE7"/>
@@ -4148,7 +3972,7 @@
                     <a:bodyPr/>
                     <a:lstStyle/>
                     <a:p>
-                      <a:pPr indent="0" marL="0">
+                      <a:pPr marL="0" indent="0">
                         <a:buNone/>
                       </a:pPr>
                       <a:r>
@@ -4169,7 +3993,7 @@
                       </a:endParaRPr>
                     </a:p>
                   </a:txBody>
-                  <a:tcPr marL="91440" marR="91440" marT="45720" marB="45720" anchor="ctr">
+                  <a:tcPr anchor="ctr">
                     <a:lnL w="12700" cap="flat" cmpd="sng" algn="ctr">
                       <a:solidFill>
                         <a:srgbClr val="D9DEE7"/>
@@ -4216,7 +4040,7 @@
                     <a:bodyPr/>
                     <a:lstStyle/>
                     <a:p>
-                      <a:pPr indent="0" marL="0">
+                      <a:pPr marL="0" indent="0">
                         <a:buNone/>
                       </a:pPr>
                       <a:r>
@@ -4237,7 +4061,7 @@
                       </a:endParaRPr>
                     </a:p>
                   </a:txBody>
-                  <a:tcPr marL="91440" marR="91440" marT="45720" marB="45720" anchor="ctr">
+                  <a:tcPr anchor="ctr">
                     <a:lnL w="12700" cap="flat" cmpd="sng" algn="ctr">
                       <a:solidFill>
                         <a:srgbClr val="D9DEE7"/>
@@ -4284,7 +4108,7 @@
                     <a:bodyPr/>
                     <a:lstStyle/>
                     <a:p>
-                      <a:pPr indent="0" marL="0">
+                      <a:pPr marL="0" indent="0">
                         <a:buNone/>
                       </a:pPr>
                       <a:r>
@@ -4305,7 +4129,7 @@
                       </a:endParaRPr>
                     </a:p>
                   </a:txBody>
-                  <a:tcPr marL="91440" marR="91440" marT="45720" marB="45720" anchor="ctr">
+                  <a:tcPr anchor="ctr">
                     <a:lnL w="12700" cap="flat" cmpd="sng" algn="ctr">
                       <a:solidFill>
                         <a:srgbClr val="D9DEE7"/>
@@ -4347,6 +4171,11 @@
                     </a:solidFill>
                   </a:tcPr>
                 </a:tc>
+                <a:extLst>
+                  <a:ext uri="{0D108BD9-81ED-4DB2-BD59-A6C34878D82A}">
+                    <a16:rowId xmlns:a16="http://schemas.microsoft.com/office/drawing/2014/main" val="10000"/>
+                  </a:ext>
+                </a:extLst>
               </a:tr>
               <a:tr h="1051560">
                 <a:tc>
@@ -4354,7 +4183,7 @@
                     <a:bodyPr/>
                     <a:lstStyle/>
                     <a:p>
-                      <a:pPr indent="0" marL="0">
+                      <a:pPr marL="0" indent="0">
                         <a:buNone/>
                       </a:pPr>
                       <a:r>
@@ -4375,7 +4204,7 @@
                       </a:endParaRPr>
                     </a:p>
                   </a:txBody>
-                  <a:tcPr marL="91440" marR="91440" marT="45720" marB="45720" anchor="ctr">
+                  <a:tcPr anchor="ctr">
                     <a:lnL w="12700" cap="flat" cmpd="sng" algn="ctr">
                       <a:solidFill>
                         <a:srgbClr val="D9DEE7"/>
@@ -4422,7 +4251,7 @@
                     <a:bodyPr/>
                     <a:lstStyle/>
                     <a:p>
-                      <a:pPr indent="0" marL="0">
+                      <a:pPr marL="0" indent="0">
                         <a:buNone/>
                       </a:pPr>
                       <a:r>
@@ -4443,7 +4272,7 @@
                       </a:endParaRPr>
                     </a:p>
                   </a:txBody>
-                  <a:tcPr marL="91440" marR="91440" marT="45720" marB="45720" anchor="ctr">
+                  <a:tcPr anchor="ctr">
                     <a:lnL w="12700" cap="flat" cmpd="sng" algn="ctr">
                       <a:solidFill>
                         <a:srgbClr val="D9DEE7"/>
@@ -4490,7 +4319,7 @@
                     <a:bodyPr/>
                     <a:lstStyle/>
                     <a:p>
-                      <a:pPr indent="0" marL="0">
+                      <a:pPr marL="0" indent="0">
                         <a:buNone/>
                       </a:pPr>
                       <a:r>
@@ -4511,7 +4340,7 @@
                       </a:endParaRPr>
                     </a:p>
                   </a:txBody>
-                  <a:tcPr marL="91440" marR="91440" marT="45720" marB="45720" anchor="ctr">
+                  <a:tcPr anchor="ctr">
                     <a:lnL w="12700" cap="flat" cmpd="sng" algn="ctr">
                       <a:solidFill>
                         <a:srgbClr val="D9DEE7"/>
@@ -4558,7 +4387,7 @@
                     <a:bodyPr/>
                     <a:lstStyle/>
                     <a:p>
-                      <a:pPr indent="0" marL="0">
+                      <a:pPr marL="0" indent="0">
                         <a:buNone/>
                       </a:pPr>
                       <a:r>
@@ -4579,7 +4408,7 @@
                       </a:endParaRPr>
                     </a:p>
                   </a:txBody>
-                  <a:tcPr marL="91440" marR="91440" marT="45720" marB="45720" anchor="ctr">
+                  <a:tcPr anchor="ctr">
                     <a:lnL w="12700" cap="flat" cmpd="sng" algn="ctr">
                       <a:solidFill>
                         <a:srgbClr val="D9DEE7"/>
@@ -4621,6 +4450,11 @@
                     </a:solidFill>
                   </a:tcPr>
                 </a:tc>
+                <a:extLst>
+                  <a:ext uri="{0D108BD9-81ED-4DB2-BD59-A6C34878D82A}">
+                    <a16:rowId xmlns:a16="http://schemas.microsoft.com/office/drawing/2014/main" val="10001"/>
+                  </a:ext>
+                </a:extLst>
               </a:tr>
               <a:tr h="1051560">
                 <a:tc>
@@ -4628,7 +4462,7 @@
                     <a:bodyPr/>
                     <a:lstStyle/>
                     <a:p>
-                      <a:pPr indent="0" marL="0">
+                      <a:pPr marL="0" indent="0">
                         <a:buNone/>
                       </a:pPr>
                       <a:r>
@@ -4649,7 +4483,7 @@
                       </a:endParaRPr>
                     </a:p>
                   </a:txBody>
-                  <a:tcPr marL="91440" marR="91440" marT="45720" marB="45720" anchor="ctr">
+                  <a:tcPr anchor="ctr">
                     <a:lnL w="12700" cap="flat" cmpd="sng" algn="ctr">
                       <a:solidFill>
                         <a:srgbClr val="D9DEE7"/>
@@ -4696,7 +4530,7 @@
                     <a:bodyPr/>
                     <a:lstStyle/>
                     <a:p>
-                      <a:pPr indent="0" marL="0">
+                      <a:pPr marL="0" indent="0">
                         <a:buNone/>
                       </a:pPr>
                       <a:r>
@@ -4717,7 +4551,7 @@
                       </a:endParaRPr>
                     </a:p>
                   </a:txBody>
-                  <a:tcPr marL="91440" marR="91440" marT="45720" marB="45720" anchor="ctr">
+                  <a:tcPr anchor="ctr">
                     <a:lnL w="12700" cap="flat" cmpd="sng" algn="ctr">
                       <a:solidFill>
                         <a:srgbClr val="D9DEE7"/>
@@ -4764,7 +4598,7 @@
                     <a:bodyPr/>
                     <a:lstStyle/>
                     <a:p>
-                      <a:pPr indent="0" marL="0">
+                      <a:pPr marL="0" indent="0">
                         <a:buNone/>
                       </a:pPr>
                       <a:r>
@@ -4785,7 +4619,7 @@
                       </a:endParaRPr>
                     </a:p>
                   </a:txBody>
-                  <a:tcPr marL="91440" marR="91440" marT="45720" marB="45720" anchor="ctr">
+                  <a:tcPr anchor="ctr">
                     <a:lnL w="12700" cap="flat" cmpd="sng" algn="ctr">
                       <a:solidFill>
                         <a:srgbClr val="D9DEE7"/>
@@ -4832,7 +4666,7 @@
                     <a:bodyPr/>
                     <a:lstStyle/>
                     <a:p>
-                      <a:pPr indent="0" marL="0">
+                      <a:pPr marL="0" indent="0">
                         <a:buNone/>
                       </a:pPr>
                       <a:r>
@@ -4853,7 +4687,7 @@
                       </a:endParaRPr>
                     </a:p>
                   </a:txBody>
-                  <a:tcPr marL="91440" marR="91440" marT="45720" marB="45720" anchor="ctr">
+                  <a:tcPr anchor="ctr">
                     <a:lnL w="12700" cap="flat" cmpd="sng" algn="ctr">
                       <a:solidFill>
                         <a:srgbClr val="D9DEE7"/>
@@ -4895,6 +4729,11 @@
                     </a:solidFill>
                   </a:tcPr>
                 </a:tc>
+                <a:extLst>
+                  <a:ext uri="{0D108BD9-81ED-4DB2-BD59-A6C34878D82A}">
+                    <a16:rowId xmlns:a16="http://schemas.microsoft.com/office/drawing/2014/main" val="10002"/>
+                  </a:ext>
+                </a:extLst>
               </a:tr>
             </a:tbl>
           </a:graphicData>
@@ -4926,13 +4765,20 @@
             <a:prstDash val="solid"/>
           </a:ln>
           <a:effectLst>
-            <a:outerShdw sx="100000" sy="100000" kx="0" ky="0" algn="bl" rotWithShape="0" blurRad="76200" dist="12700" dir="5400000">
+            <a:outerShdw blurRad="76200" dist="12700" dir="5400000" algn="bl" rotWithShape="0">
               <a:srgbClr val="9AA4B2">
                 <a:alpha val="18000"/>
               </a:srgbClr>
             </a:outerShdw>
           </a:effectLst>
         </p:spPr>
+        <p:txBody>
+          <a:bodyPr/>
+          <a:lstStyle/>
+          <a:p>
+            <a:endParaRPr lang="en-AU"/>
+          </a:p>
+        </p:txBody>
       </p:sp>
       <p:sp>
         <p:nvSpPr>
@@ -4955,7 +4801,7 @@
           <a:bodyPr wrap="square" lIns="0" tIns="0" rIns="0" bIns="0" rtlCol="0" anchor="ctr"/>
           <a:lstStyle/>
           <a:p>
-            <a:pPr indent="0" marL="0">
+            <a:pPr marL="0" indent="0">
               <a:lnSpc>
                 <a:spcPts val="2400"/>
               </a:lnSpc>
@@ -4992,6 +4838,7 @@
         <a:solidFill>
           <a:srgbClr val="FFFFFF"/>
         </a:solidFill>
+        <a:effectLst/>
       </p:bgPr>
     </p:bg>
     <p:spTree>
@@ -5029,11 +4876,11 @@
           <a:bodyPr wrap="square" lIns="0" tIns="0" rIns="0" bIns="0" rtlCol="0" anchor="ctr"/>
           <a:lstStyle/>
           <a:p>
-            <a:pPr indent="0" marL="0">
-              <a:buNone/>
-            </a:pPr>
-            <a:r>
-              <a:rPr lang="en-US" sz="1200" b="1" spc="160" kern="0" dirty="0">
+            <a:pPr marL="0" indent="0">
+              <a:buNone/>
+            </a:pPr>
+            <a:r>
+              <a:rPr lang="en-US" sz="1200" b="1" kern="0" spc="160" dirty="0">
                 <a:solidFill>
                   <a:srgbClr val="6B7280"/>
                 </a:solidFill>
@@ -5068,7 +4915,7 @@
           <a:bodyPr wrap="square" lIns="0" tIns="0" rIns="0" bIns="0" rtlCol="0" anchor="t"/>
           <a:lstStyle/>
           <a:p>
-            <a:pPr indent="0" marL="0">
+            <a:pPr marL="0" indent="0">
               <a:buNone/>
             </a:pPr>
             <a:r>
@@ -5112,6 +4959,13 @@
             <a:prstDash val="solid"/>
           </a:ln>
         </p:spPr>
+        <p:txBody>
+          <a:bodyPr/>
+          <a:lstStyle/>
+          <a:p>
+            <a:endParaRPr lang="en-AU"/>
+          </a:p>
+        </p:txBody>
       </p:sp>
       <p:sp>
         <p:nvSpPr>
@@ -5134,11 +4988,11 @@
           <a:bodyPr wrap="square" lIns="0" tIns="0" rIns="0" bIns="0" rtlCol="0" anchor="ctr"/>
           <a:lstStyle/>
           <a:p>
-            <a:pPr algn="ctr" indent="0" marL="0">
-              <a:buNone/>
-            </a:pPr>
-            <a:r>
-              <a:rPr lang="en-US" sz="1200" b="1" spc="120" kern="0" dirty="0">
+            <a:pPr marL="0" indent="0" algn="ctr">
+              <a:buNone/>
+            </a:pPr>
+            <a:r>
+              <a:rPr lang="en-US" sz="1200" b="1" kern="0" spc="120" dirty="0">
                 <a:solidFill>
                   <a:srgbClr val="FFFFFF"/>
                 </a:solidFill>
@@ -5178,6 +5032,13 @@
             <a:prstDash val="solid"/>
           </a:ln>
         </p:spPr>
+        <p:txBody>
+          <a:bodyPr/>
+          <a:lstStyle/>
+          <a:p>
+            <a:endParaRPr lang="en-AU"/>
+          </a:p>
+        </p:txBody>
       </p:sp>
       <p:sp>
         <p:nvSpPr>
@@ -5200,11 +5061,11 @@
           <a:bodyPr wrap="square" lIns="0" tIns="0" rIns="0" bIns="0" rtlCol="0" anchor="ctr"/>
           <a:lstStyle/>
           <a:p>
-            <a:pPr algn="ctr" indent="0" marL="0">
-              <a:buNone/>
-            </a:pPr>
-            <a:r>
-              <a:rPr lang="en-US" sz="1100" b="1" spc="100" kern="0" dirty="0">
+            <a:pPr marL="0" indent="0" algn="ctr">
+              <a:buNone/>
+            </a:pPr>
+            <a:r>
+              <a:rPr lang="en-US" sz="1100" b="1" kern="0" spc="100" dirty="0">
                 <a:solidFill>
                   <a:srgbClr val="10B981"/>
                 </a:solidFill>
@@ -5244,13 +5105,20 @@
             <a:prstDash val="solid"/>
           </a:ln>
           <a:effectLst>
-            <a:outerShdw sx="100000" sy="100000" kx="0" ky="0" algn="bl" rotWithShape="0" blurRad="76200" dist="12700" dir="5400000">
+            <a:outerShdw blurRad="76200" dist="12700" dir="5400000" algn="bl" rotWithShape="0">
               <a:srgbClr val="9AA4B2">
                 <a:alpha val="18000"/>
               </a:srgbClr>
             </a:outerShdw>
           </a:effectLst>
         </p:spPr>
+        <p:txBody>
+          <a:bodyPr/>
+          <a:lstStyle/>
+          <a:p>
+            <a:endParaRPr lang="en-AU"/>
+          </a:p>
+        </p:txBody>
       </p:sp>
       <p:sp>
         <p:nvSpPr>
@@ -5276,6 +5144,13 @@
             <a:prstDash val="solid"/>
           </a:ln>
         </p:spPr>
+        <p:txBody>
+          <a:bodyPr/>
+          <a:lstStyle/>
+          <a:p>
+            <a:endParaRPr lang="en-AU"/>
+          </a:p>
+        </p:txBody>
       </p:sp>
       <p:sp>
         <p:nvSpPr>
@@ -5298,7 +5173,7 @@
           <a:bodyPr wrap="square" lIns="0" tIns="0" rIns="0" bIns="0" rtlCol="0" anchor="ctr"/>
           <a:lstStyle/>
           <a:p>
-            <a:pPr algn="ctr" indent="0" marL="0">
+            <a:pPr marL="0" indent="0" algn="ctr">
               <a:buNone/>
             </a:pPr>
             <a:r>
@@ -5337,7 +5212,7 @@
           <a:bodyPr wrap="square" lIns="0" tIns="0" rIns="0" bIns="0" rtlCol="0" anchor="ctr"/>
           <a:lstStyle/>
           <a:p>
-            <a:pPr indent="0" marL="0">
+            <a:pPr marL="0" indent="0">
               <a:buNone/>
             </a:pPr>
             <a:r>
@@ -5376,7 +5251,7 @@
           <a:bodyPr wrap="square" lIns="0" tIns="0" rIns="0" bIns="0" rtlCol="0" anchor="ctr"/>
           <a:lstStyle/>
           <a:p>
-            <a:pPr indent="0" marL="0">
+            <a:pPr marL="0" indent="0">
               <a:buNone/>
             </a:pPr>
             <a:r>
@@ -5420,13 +5295,20 @@
             <a:prstDash val="solid"/>
           </a:ln>
           <a:effectLst>
-            <a:outerShdw sx="100000" sy="100000" kx="0" ky="0" algn="bl" rotWithShape="0" blurRad="76200" dist="12700" dir="5400000">
+            <a:outerShdw blurRad="76200" dist="12700" dir="5400000" algn="bl" rotWithShape="0">
               <a:srgbClr val="9AA4B2">
                 <a:alpha val="18000"/>
               </a:srgbClr>
             </a:outerShdw>
           </a:effectLst>
         </p:spPr>
+        <p:txBody>
+          <a:bodyPr/>
+          <a:lstStyle/>
+          <a:p>
+            <a:endParaRPr lang="en-AU"/>
+          </a:p>
+        </p:txBody>
       </p:sp>
       <p:sp>
         <p:nvSpPr>
@@ -5452,6 +5334,13 @@
             <a:prstDash val="solid"/>
           </a:ln>
         </p:spPr>
+        <p:txBody>
+          <a:bodyPr/>
+          <a:lstStyle/>
+          <a:p>
+            <a:endParaRPr lang="en-AU"/>
+          </a:p>
+        </p:txBody>
       </p:sp>
       <p:sp>
         <p:nvSpPr>
@@ -5474,7 +5363,7 @@
           <a:bodyPr wrap="square" lIns="0" tIns="0" rIns="0" bIns="0" rtlCol="0" anchor="ctr"/>
           <a:lstStyle/>
           <a:p>
-            <a:pPr algn="ctr" indent="0" marL="0">
+            <a:pPr marL="0" indent="0" algn="ctr">
               <a:buNone/>
             </a:pPr>
             <a:r>
@@ -5513,7 +5402,7 @@
           <a:bodyPr wrap="square" lIns="0" tIns="0" rIns="0" bIns="0" rtlCol="0" anchor="ctr"/>
           <a:lstStyle/>
           <a:p>
-            <a:pPr indent="0" marL="0">
+            <a:pPr marL="0" indent="0">
               <a:buNone/>
             </a:pPr>
             <a:r>
@@ -5552,7 +5441,7 @@
           <a:bodyPr wrap="square" lIns="0" tIns="0" rIns="0" bIns="0" rtlCol="0" anchor="ctr"/>
           <a:lstStyle/>
           <a:p>
-            <a:pPr indent="0" marL="0">
+            <a:pPr marL="0" indent="0">
               <a:buNone/>
             </a:pPr>
             <a:r>
@@ -5596,13 +5485,20 @@
             <a:prstDash val="solid"/>
           </a:ln>
           <a:effectLst>
-            <a:outerShdw sx="100000" sy="100000" kx="0" ky="0" algn="bl" rotWithShape="0" blurRad="76200" dist="12700" dir="5400000">
+            <a:outerShdw blurRad="76200" dist="12700" dir="5400000" algn="bl" rotWithShape="0">
               <a:srgbClr val="9AA4B2">
                 <a:alpha val="18000"/>
               </a:srgbClr>
             </a:outerShdw>
           </a:effectLst>
         </p:spPr>
+        <p:txBody>
+          <a:bodyPr/>
+          <a:lstStyle/>
+          <a:p>
+            <a:endParaRPr lang="en-AU"/>
+          </a:p>
+        </p:txBody>
       </p:sp>
       <p:sp>
         <p:nvSpPr>
@@ -5628,6 +5524,13 @@
             <a:prstDash val="solid"/>
           </a:ln>
         </p:spPr>
+        <p:txBody>
+          <a:bodyPr/>
+          <a:lstStyle/>
+          <a:p>
+            <a:endParaRPr lang="en-AU"/>
+          </a:p>
+        </p:txBody>
       </p:sp>
       <p:sp>
         <p:nvSpPr>
@@ -5650,7 +5553,7 @@
           <a:bodyPr wrap="square" lIns="0" tIns="0" rIns="0" bIns="0" rtlCol="0" anchor="ctr"/>
           <a:lstStyle/>
           <a:p>
-            <a:pPr algn="ctr" indent="0" marL="0">
+            <a:pPr marL="0" indent="0" algn="ctr">
               <a:buNone/>
             </a:pPr>
             <a:r>
@@ -5689,7 +5592,7 @@
           <a:bodyPr wrap="square" lIns="0" tIns="0" rIns="0" bIns="0" rtlCol="0" anchor="ctr"/>
           <a:lstStyle/>
           <a:p>
-            <a:pPr indent="0" marL="0">
+            <a:pPr marL="0" indent="0">
               <a:buNone/>
             </a:pPr>
             <a:r>
@@ -5728,7 +5631,7 @@
           <a:bodyPr wrap="square" lIns="0" tIns="0" rIns="0" bIns="0" rtlCol="0" anchor="ctr"/>
           <a:lstStyle/>
           <a:p>
-            <a:pPr indent="0" marL="0">
+            <a:pPr marL="0" indent="0">
               <a:buNone/>
             </a:pPr>
             <a:r>
@@ -5772,13 +5675,20 @@
             <a:prstDash val="solid"/>
           </a:ln>
           <a:effectLst>
-            <a:outerShdw sx="100000" sy="100000" kx="0" ky="0" algn="bl" rotWithShape="0" blurRad="76200" dist="12700" dir="5400000">
+            <a:outerShdw blurRad="76200" dist="12700" dir="5400000" algn="bl" rotWithShape="0">
               <a:srgbClr val="9AA4B2">
                 <a:alpha val="18000"/>
               </a:srgbClr>
             </a:outerShdw>
           </a:effectLst>
         </p:spPr>
+        <p:txBody>
+          <a:bodyPr/>
+          <a:lstStyle/>
+          <a:p>
+            <a:endParaRPr lang="en-AU"/>
+          </a:p>
+        </p:txBody>
       </p:sp>
       <p:sp>
         <p:nvSpPr>
@@ -5804,6 +5714,13 @@
             <a:prstDash val="solid"/>
           </a:ln>
         </p:spPr>
+        <p:txBody>
+          <a:bodyPr/>
+          <a:lstStyle/>
+          <a:p>
+            <a:endParaRPr lang="en-AU"/>
+          </a:p>
+        </p:txBody>
       </p:sp>
       <p:sp>
         <p:nvSpPr>
@@ -5826,7 +5743,7 @@
           <a:bodyPr wrap="square" lIns="0" tIns="0" rIns="0" bIns="0" rtlCol="0" anchor="ctr"/>
           <a:lstStyle/>
           <a:p>
-            <a:pPr algn="ctr" indent="0" marL="0">
+            <a:pPr marL="0" indent="0" algn="ctr">
               <a:buNone/>
             </a:pPr>
             <a:r>
@@ -5865,7 +5782,7 @@
           <a:bodyPr wrap="square" lIns="0" tIns="0" rIns="0" bIns="0" rtlCol="0" anchor="ctr"/>
           <a:lstStyle/>
           <a:p>
-            <a:pPr indent="0" marL="0">
+            <a:pPr marL="0" indent="0">
               <a:buNone/>
             </a:pPr>
             <a:r>
@@ -5904,7 +5821,7 @@
           <a:bodyPr wrap="square" lIns="0" tIns="0" rIns="0" bIns="0" rtlCol="0" anchor="ctr"/>
           <a:lstStyle/>
           <a:p>
-            <a:pPr indent="0" marL="0">
+            <a:pPr marL="0" indent="0">
               <a:buNone/>
             </a:pPr>
             <a:r>
@@ -5948,13 +5865,20 @@
             <a:prstDash val="solid"/>
           </a:ln>
           <a:effectLst>
-            <a:outerShdw sx="100000" sy="100000" kx="0" ky="0" algn="bl" rotWithShape="0" blurRad="76200" dist="12700" dir="5400000">
+            <a:outerShdw blurRad="76200" dist="12700" dir="5400000" algn="bl" rotWithShape="0">
               <a:srgbClr val="9AA4B2">
                 <a:alpha val="18000"/>
               </a:srgbClr>
             </a:outerShdw>
           </a:effectLst>
         </p:spPr>
+        <p:txBody>
+          <a:bodyPr/>
+          <a:lstStyle/>
+          <a:p>
+            <a:endParaRPr lang="en-AU"/>
+          </a:p>
+        </p:txBody>
       </p:sp>
       <p:sp>
         <p:nvSpPr>
@@ -5977,7 +5901,7 @@
           <a:bodyPr wrap="square" lIns="0" tIns="0" rIns="0" bIns="0" rtlCol="0" anchor="ctr"/>
           <a:lstStyle/>
           <a:p>
-            <a:pPr indent="0" marL="0">
+            <a:pPr marL="0" indent="0">
               <a:buNone/>
             </a:pPr>
             <a:r>
@@ -6011,6 +5935,7 @@
         <a:solidFill>
           <a:srgbClr val="FFFFFF"/>
         </a:solidFill>
+        <a:effectLst/>
       </p:bgPr>
     </p:bg>
     <p:spTree>
@@ -6048,11 +5973,11 @@
           <a:bodyPr wrap="square" lIns="0" tIns="0" rIns="0" bIns="0" rtlCol="0" anchor="ctr"/>
           <a:lstStyle/>
           <a:p>
-            <a:pPr indent="0" marL="0">
-              <a:buNone/>
-            </a:pPr>
-            <a:r>
-              <a:rPr lang="en-US" sz="1200" b="1" spc="160" kern="0" dirty="0">
+            <a:pPr marL="0" indent="0">
+              <a:buNone/>
+            </a:pPr>
+            <a:r>
+              <a:rPr lang="en-US" sz="1200" b="1" kern="0" spc="160" dirty="0">
                 <a:solidFill>
                   <a:srgbClr val="6B7280"/>
                 </a:solidFill>
@@ -6087,7 +6012,7 @@
           <a:bodyPr wrap="square" lIns="0" tIns="0" rIns="0" bIns="0" rtlCol="0" anchor="t"/>
           <a:lstStyle/>
           <a:p>
-            <a:pPr indent="0" marL="0">
+            <a:pPr marL="0" indent="0">
               <a:buNone/>
             </a:pPr>
             <a:r>
@@ -6131,6 +6056,13 @@
             <a:prstDash val="solid"/>
           </a:ln>
         </p:spPr>
+        <p:txBody>
+          <a:bodyPr/>
+          <a:lstStyle/>
+          <a:p>
+            <a:endParaRPr lang="en-AU"/>
+          </a:p>
+        </p:txBody>
       </p:sp>
       <p:sp>
         <p:nvSpPr>
@@ -6153,11 +6085,11 @@
           <a:bodyPr wrap="square" lIns="0" tIns="0" rIns="0" bIns="0" rtlCol="0" anchor="ctr"/>
           <a:lstStyle/>
           <a:p>
-            <a:pPr algn="ctr" indent="0" marL="0">
-              <a:buNone/>
-            </a:pPr>
-            <a:r>
-              <a:rPr lang="en-US" sz="1200" b="1" spc="120" kern="0" dirty="0">
+            <a:pPr marL="0" indent="0" algn="ctr">
+              <a:buNone/>
+            </a:pPr>
+            <a:r>
+              <a:rPr lang="en-US" sz="1200" b="1" kern="0" spc="120" dirty="0">
                 <a:solidFill>
                   <a:srgbClr val="FFFFFF"/>
                 </a:solidFill>
@@ -6197,6 +6129,13 @@
             <a:prstDash val="solid"/>
           </a:ln>
         </p:spPr>
+        <p:txBody>
+          <a:bodyPr/>
+          <a:lstStyle/>
+          <a:p>
+            <a:endParaRPr lang="en-AU"/>
+          </a:p>
+        </p:txBody>
       </p:sp>
       <p:sp>
         <p:nvSpPr>
@@ -6219,11 +6158,11 @@
           <a:bodyPr wrap="square" lIns="0" tIns="0" rIns="0" bIns="0" rtlCol="0" anchor="ctr"/>
           <a:lstStyle/>
           <a:p>
-            <a:pPr algn="ctr" indent="0" marL="0">
-              <a:buNone/>
-            </a:pPr>
-            <a:r>
-              <a:rPr lang="en-US" sz="1100" b="1" spc="100" kern="0" dirty="0">
+            <a:pPr marL="0" indent="0" algn="ctr">
+              <a:buNone/>
+            </a:pPr>
+            <a:r>
+              <a:rPr lang="en-US" sz="1100" b="1" kern="0" spc="100" dirty="0">
                 <a:solidFill>
                   <a:srgbClr val="10B981"/>
                 </a:solidFill>
@@ -6258,7 +6197,7 @@
           <a:bodyPr wrap="square" lIns="0" tIns="0" rIns="0" bIns="0" rtlCol="0" anchor="ctr"/>
           <a:lstStyle/>
           <a:p>
-            <a:pPr indent="0" marL="0">
+            <a:pPr marL="0" indent="0">
               <a:buNone/>
             </a:pPr>
             <a:r>
@@ -6302,13 +6241,20 @@
             <a:prstDash val="solid"/>
           </a:ln>
           <a:effectLst>
-            <a:outerShdw sx="100000" sy="100000" kx="0" ky="0" algn="bl" rotWithShape="0" blurRad="76200" dist="12700" dir="5400000">
+            <a:outerShdw blurRad="76200" dist="12700" dir="5400000" algn="bl" rotWithShape="0">
               <a:srgbClr val="9AA4B2">
                 <a:alpha val="18000"/>
               </a:srgbClr>
             </a:outerShdw>
           </a:effectLst>
         </p:spPr>
+        <p:txBody>
+          <a:bodyPr/>
+          <a:lstStyle/>
+          <a:p>
+            <a:endParaRPr lang="en-AU"/>
+          </a:p>
+        </p:txBody>
       </p:sp>
       <p:sp>
         <p:nvSpPr>
@@ -6331,7 +6277,7 @@
           <a:bodyPr wrap="square" lIns="0" tIns="0" rIns="0" bIns="0" rtlCol="0" anchor="ctr"/>
           <a:lstStyle/>
           <a:p>
-            <a:pPr indent="0" marL="0">
+            <a:pPr marL="0" indent="0">
               <a:buNone/>
             </a:pPr>
             <a:r>
@@ -6375,13 +6321,20 @@
             <a:prstDash val="solid"/>
           </a:ln>
           <a:effectLst>
-            <a:outerShdw sx="100000" sy="100000" kx="0" ky="0" algn="bl" rotWithShape="0" blurRad="76200" dist="12700" dir="5400000">
+            <a:outerShdw blurRad="76200" dist="12700" dir="5400000" algn="bl" rotWithShape="0">
               <a:srgbClr val="9AA4B2">
                 <a:alpha val="18000"/>
               </a:srgbClr>
             </a:outerShdw>
           </a:effectLst>
         </p:spPr>
+        <p:txBody>
+          <a:bodyPr/>
+          <a:lstStyle/>
+          <a:p>
+            <a:endParaRPr lang="en-AU"/>
+          </a:p>
+        </p:txBody>
       </p:sp>
       <p:sp>
         <p:nvSpPr>
@@ -6404,7 +6357,7 @@
           <a:bodyPr wrap="square" lIns="0" tIns="0" rIns="0" bIns="0" rtlCol="0" anchor="ctr"/>
           <a:lstStyle/>
           <a:p>
-            <a:pPr indent="0" marL="0">
+            <a:pPr marL="0" indent="0">
               <a:buNone/>
             </a:pPr>
             <a:r>
@@ -6448,13 +6401,20 @@
             <a:prstDash val="solid"/>
           </a:ln>
           <a:effectLst>
-            <a:outerShdw sx="100000" sy="100000" kx="0" ky="0" algn="bl" rotWithShape="0" blurRad="76200" dist="12700" dir="5400000">
+            <a:outerShdw blurRad="76200" dist="12700" dir="5400000" algn="bl" rotWithShape="0">
               <a:srgbClr val="9AA4B2">
                 <a:alpha val="18000"/>
               </a:srgbClr>
             </a:outerShdw>
           </a:effectLst>
         </p:spPr>
+        <p:txBody>
+          <a:bodyPr/>
+          <a:lstStyle/>
+          <a:p>
+            <a:endParaRPr lang="en-AU"/>
+          </a:p>
+        </p:txBody>
       </p:sp>
       <p:sp>
         <p:nvSpPr>
@@ -6477,7 +6437,7 @@
           <a:bodyPr wrap="square" lIns="0" tIns="0" rIns="0" bIns="0" rtlCol="0" anchor="ctr"/>
           <a:lstStyle/>
           <a:p>
-            <a:pPr indent="0" marL="0">
+            <a:pPr marL="0" indent="0">
               <a:buNone/>
             </a:pPr>
             <a:r>
@@ -6516,7 +6476,7 @@
           <a:bodyPr wrap="square" lIns="0" tIns="0" rIns="0" bIns="0" rtlCol="0" anchor="ctr"/>
           <a:lstStyle/>
           <a:p>
-            <a:pPr indent="0" marL="0">
+            <a:pPr marL="0" indent="0">
               <a:buNone/>
             </a:pPr>
             <a:r>
@@ -6550,6 +6510,7 @@
         <a:solidFill>
           <a:srgbClr val="FFFFFF"/>
         </a:solidFill>
+        <a:effectLst/>
       </p:bgPr>
     </p:bg>
     <p:spTree>
@@ -6587,11 +6548,11 @@
           <a:bodyPr wrap="square" lIns="0" tIns="0" rIns="0" bIns="0" rtlCol="0" anchor="ctr"/>
           <a:lstStyle/>
           <a:p>
-            <a:pPr indent="0" marL="0">
-              <a:buNone/>
-            </a:pPr>
-            <a:r>
-              <a:rPr lang="en-US" sz="1200" b="1" spc="160" kern="0" dirty="0">
+            <a:pPr marL="0" indent="0">
+              <a:buNone/>
+            </a:pPr>
+            <a:r>
+              <a:rPr lang="en-US" sz="1200" b="1" kern="0" spc="160" dirty="0">
                 <a:solidFill>
                   <a:srgbClr val="6B7280"/>
                 </a:solidFill>
@@ -6626,7 +6587,7 @@
           <a:bodyPr wrap="square" lIns="0" tIns="0" rIns="0" bIns="0" rtlCol="0" anchor="t"/>
           <a:lstStyle/>
           <a:p>
-            <a:pPr indent="0" marL="0">
+            <a:pPr marL="0" indent="0">
               <a:buNone/>
             </a:pPr>
             <a:r>
@@ -6670,6 +6631,13 @@
             <a:prstDash val="solid"/>
           </a:ln>
         </p:spPr>
+        <p:txBody>
+          <a:bodyPr/>
+          <a:lstStyle/>
+          <a:p>
+            <a:endParaRPr lang="en-AU"/>
+          </a:p>
+        </p:txBody>
       </p:sp>
       <p:sp>
         <p:nvSpPr>
@@ -6692,11 +6660,11 @@
           <a:bodyPr wrap="square" lIns="0" tIns="0" rIns="0" bIns="0" rtlCol="0" anchor="ctr"/>
           <a:lstStyle/>
           <a:p>
-            <a:pPr algn="ctr" indent="0" marL="0">
-              <a:buNone/>
-            </a:pPr>
-            <a:r>
-              <a:rPr lang="en-US" sz="1200" b="1" spc="120" kern="0" dirty="0">
+            <a:pPr marL="0" indent="0" algn="ctr">
+              <a:buNone/>
+            </a:pPr>
+            <a:r>
+              <a:rPr lang="en-US" sz="1200" b="1" kern="0" spc="120" dirty="0">
                 <a:solidFill>
                   <a:srgbClr val="FFFFFF"/>
                 </a:solidFill>
@@ -6736,6 +6704,13 @@
             <a:prstDash val="solid"/>
           </a:ln>
         </p:spPr>
+        <p:txBody>
+          <a:bodyPr/>
+          <a:lstStyle/>
+          <a:p>
+            <a:endParaRPr lang="en-AU"/>
+          </a:p>
+        </p:txBody>
       </p:sp>
       <p:sp>
         <p:nvSpPr>
@@ -6758,11 +6733,11 @@
           <a:bodyPr wrap="square" lIns="0" tIns="0" rIns="0" bIns="0" rtlCol="0" anchor="ctr"/>
           <a:lstStyle/>
           <a:p>
-            <a:pPr algn="ctr" indent="0" marL="0">
-              <a:buNone/>
-            </a:pPr>
-            <a:r>
-              <a:rPr lang="en-US" sz="1100" b="1" spc="100" kern="0" dirty="0">
+            <a:pPr marL="0" indent="0" algn="ctr">
+              <a:buNone/>
+            </a:pPr>
+            <a:r>
+              <a:rPr lang="en-US" sz="1100" b="1" kern="0" spc="100" dirty="0">
                 <a:solidFill>
                   <a:srgbClr val="EF4444"/>
                 </a:solidFill>
@@ -6802,13 +6777,20 @@
             <a:prstDash val="solid"/>
           </a:ln>
           <a:effectLst>
-            <a:outerShdw sx="100000" sy="100000" kx="0" ky="0" algn="bl" rotWithShape="0" blurRad="76200" dist="12700" dir="5400000">
+            <a:outerShdw blurRad="76200" dist="12700" dir="5400000" algn="bl" rotWithShape="0">
               <a:srgbClr val="9AA4B2">
                 <a:alpha val="18000"/>
               </a:srgbClr>
             </a:outerShdw>
           </a:effectLst>
         </p:spPr>
+        <p:txBody>
+          <a:bodyPr/>
+          <a:lstStyle/>
+          <a:p>
+            <a:endParaRPr lang="en-AU"/>
+          </a:p>
+        </p:txBody>
       </p:sp>
       <p:sp>
         <p:nvSpPr>
@@ -6831,7 +6813,7 @@
           <a:bodyPr wrap="square" lIns="0" tIns="0" rIns="0" bIns="0" rtlCol="0" anchor="ctr"/>
           <a:lstStyle/>
           <a:p>
-            <a:pPr indent="0" marL="0">
+            <a:pPr marL="0" indent="0">
               <a:buNone/>
             </a:pPr>
             <a:r>
@@ -6981,13 +6963,20 @@
             <a:prstDash val="solid"/>
           </a:ln>
           <a:effectLst>
-            <a:outerShdw sx="100000" sy="100000" kx="0" ky="0" algn="bl" rotWithShape="0" blurRad="76200" dist="12700" dir="5400000">
+            <a:outerShdw blurRad="76200" dist="12700" dir="5400000" algn="bl" rotWithShape="0">
               <a:srgbClr val="9AA4B2">
                 <a:alpha val="18000"/>
               </a:srgbClr>
             </a:outerShdw>
           </a:effectLst>
         </p:spPr>
+        <p:txBody>
+          <a:bodyPr/>
+          <a:lstStyle/>
+          <a:p>
+            <a:endParaRPr lang="en-AU"/>
+          </a:p>
+        </p:txBody>
       </p:sp>
       <p:sp>
         <p:nvSpPr>
@@ -7010,7 +6999,7 @@
           <a:bodyPr wrap="square" lIns="0" tIns="0" rIns="0" bIns="0" rtlCol="0" anchor="ctr"/>
           <a:lstStyle/>
           <a:p>
-            <a:pPr indent="0" marL="0">
+            <a:pPr marL="0" indent="0">
               <a:buNone/>
             </a:pPr>
             <a:r>
@@ -7049,7 +7038,7 @@
           <a:bodyPr wrap="square" lIns="0" tIns="0" rIns="0" bIns="0" rtlCol="0" anchor="ctr"/>
           <a:lstStyle/>
           <a:p>
-            <a:pPr indent="0" marL="0">
+            <a:pPr marL="0" indent="0">
               <a:lnSpc>
                 <a:spcPts val="2400"/>
               </a:lnSpc>
@@ -7069,7 +7058,7 @@
             <a:endParaRPr lang="en-US" sz="1800" dirty="0"/>
           </a:p>
           <a:p>
-            <a:pPr indent="0" marL="0">
+            <a:pPr marL="0" indent="0">
               <a:lnSpc>
                 <a:spcPts val="2400"/>
               </a:lnSpc>
@@ -7078,7 +7067,7 @@
             <a:endParaRPr lang="en-US" sz="1800" dirty="0"/>
           </a:p>
           <a:p>
-            <a:pPr indent="0" marL="0">
+            <a:pPr marL="0" indent="0">
               <a:lnSpc>
                 <a:spcPts val="2400"/>
               </a:lnSpc>
@@ -7125,13 +7114,20 @@
             <a:prstDash val="solid"/>
           </a:ln>
           <a:effectLst>
-            <a:outerShdw sx="100000" sy="100000" kx="0" ky="0" algn="bl" rotWithShape="0" blurRad="76200" dist="12700" dir="5400000">
+            <a:outerShdw blurRad="76200" dist="12700" dir="5400000" algn="bl" rotWithShape="0">
               <a:srgbClr val="9AA4B2">
                 <a:alpha val="18000"/>
               </a:srgbClr>
             </a:outerShdw>
           </a:effectLst>
         </p:spPr>
+        <p:txBody>
+          <a:bodyPr/>
+          <a:lstStyle/>
+          <a:p>
+            <a:endParaRPr lang="en-AU"/>
+          </a:p>
+        </p:txBody>
       </p:sp>
       <p:sp>
         <p:nvSpPr>
@@ -7154,7 +7150,7 @@
           <a:bodyPr wrap="square" lIns="0" tIns="0" rIns="0" bIns="0" rtlCol="0" anchor="ctr"/>
           <a:lstStyle/>
           <a:p>
-            <a:pPr indent="0" marL="0">
+            <a:pPr marL="0" indent="0">
               <a:buNone/>
             </a:pPr>
             <a:r>
@@ -7193,7 +7189,7 @@
           <a:bodyPr wrap="square" lIns="0" tIns="0" rIns="0" bIns="0" rtlCol="0" anchor="ctr"/>
           <a:lstStyle/>
           <a:p>
-            <a:pPr indent="0" marL="0">
+            <a:pPr marL="0" indent="0">
               <a:buNone/>
             </a:pPr>
             <a:r>
@@ -7232,7 +7228,7 @@
           <a:bodyPr wrap="square" lIns="0" tIns="0" rIns="0" bIns="0" rtlCol="0" anchor="ctr"/>
           <a:lstStyle/>
           <a:p>
-            <a:pPr indent="0" marL="0">
+            <a:pPr marL="0" indent="0">
               <a:buNone/>
             </a:pPr>
             <a:r>
@@ -7266,6 +7262,7 @@
         <a:solidFill>
           <a:srgbClr val="FFFFFF"/>
         </a:solidFill>
+        <a:effectLst/>
       </p:bgPr>
     </p:bg>
     <p:spTree>
@@ -7303,11 +7300,11 @@
           <a:bodyPr wrap="square" lIns="0" tIns="0" rIns="0" bIns="0" rtlCol="0" anchor="ctr"/>
           <a:lstStyle/>
           <a:p>
-            <a:pPr indent="0" marL="0">
-              <a:buNone/>
-            </a:pPr>
-            <a:r>
-              <a:rPr lang="en-US" sz="1200" b="1" spc="160" kern="0" dirty="0">
+            <a:pPr marL="0" indent="0">
+              <a:buNone/>
+            </a:pPr>
+            <a:r>
+              <a:rPr lang="en-US" sz="1200" b="1" kern="0" spc="160" dirty="0">
                 <a:solidFill>
                   <a:srgbClr val="6B7280"/>
                 </a:solidFill>
@@ -7342,7 +7339,7 @@
           <a:bodyPr wrap="square" lIns="0" tIns="0" rIns="0" bIns="0" rtlCol="0" anchor="t"/>
           <a:lstStyle/>
           <a:p>
-            <a:pPr indent="0" marL="0">
+            <a:pPr marL="0" indent="0">
               <a:buNone/>
             </a:pPr>
             <a:r>
@@ -7386,6 +7383,13 @@
             <a:prstDash val="solid"/>
           </a:ln>
         </p:spPr>
+        <p:txBody>
+          <a:bodyPr/>
+          <a:lstStyle/>
+          <a:p>
+            <a:endParaRPr lang="en-AU"/>
+          </a:p>
+        </p:txBody>
       </p:sp>
       <p:sp>
         <p:nvSpPr>
@@ -7408,11 +7412,11 @@
           <a:bodyPr wrap="square" lIns="0" tIns="0" rIns="0" bIns="0" rtlCol="0" anchor="ctr"/>
           <a:lstStyle/>
           <a:p>
-            <a:pPr algn="ctr" indent="0" marL="0">
-              <a:buNone/>
-            </a:pPr>
-            <a:r>
-              <a:rPr lang="en-US" sz="1200" b="1" spc="120" kern="0" dirty="0">
+            <a:pPr marL="0" indent="0" algn="ctr">
+              <a:buNone/>
+            </a:pPr>
+            <a:r>
+              <a:rPr lang="en-US" sz="1200" b="1" kern="0" spc="120" dirty="0">
                 <a:solidFill>
                   <a:srgbClr val="FFFFFF"/>
                 </a:solidFill>
@@ -7452,6 +7456,13 @@
             <a:prstDash val="solid"/>
           </a:ln>
         </p:spPr>
+        <p:txBody>
+          <a:bodyPr/>
+          <a:lstStyle/>
+          <a:p>
+            <a:endParaRPr lang="en-AU"/>
+          </a:p>
+        </p:txBody>
       </p:sp>
       <p:sp>
         <p:nvSpPr>
@@ -7474,11 +7485,11 @@
           <a:bodyPr wrap="square" lIns="0" tIns="0" rIns="0" bIns="0" rtlCol="0" anchor="ctr"/>
           <a:lstStyle/>
           <a:p>
-            <a:pPr algn="ctr" indent="0" marL="0">
-              <a:buNone/>
-            </a:pPr>
-            <a:r>
-              <a:rPr lang="en-US" sz="1100" b="1" spc="100" kern="0" dirty="0">
+            <a:pPr marL="0" indent="0" algn="ctr">
+              <a:buNone/>
+            </a:pPr>
+            <a:r>
+              <a:rPr lang="en-US" sz="1100" b="1" kern="0" spc="100" dirty="0">
                 <a:solidFill>
                   <a:srgbClr val="EF4444"/>
                 </a:solidFill>
@@ -7518,13 +7529,20 @@
             <a:prstDash val="solid"/>
           </a:ln>
           <a:effectLst>
-            <a:outerShdw sx="100000" sy="100000" kx="0" ky="0" algn="bl" rotWithShape="0" blurRad="76200" dist="12700" dir="5400000">
+            <a:outerShdw blurRad="76200" dist="12700" dir="5400000" algn="bl" rotWithShape="0">
               <a:srgbClr val="9AA4B2">
                 <a:alpha val="18000"/>
               </a:srgbClr>
             </a:outerShdw>
           </a:effectLst>
         </p:spPr>
+        <p:txBody>
+          <a:bodyPr/>
+          <a:lstStyle/>
+          <a:p>
+            <a:endParaRPr lang="en-AU"/>
+          </a:p>
+        </p:txBody>
       </p:sp>
       <p:sp>
         <p:nvSpPr>
@@ -7547,7 +7565,7 @@
           <a:bodyPr wrap="square" lIns="0" tIns="0" rIns="0" bIns="0" rtlCol="0" anchor="ctr"/>
           <a:lstStyle/>
           <a:p>
-            <a:pPr indent="0" marL="0">
+            <a:pPr marL="0" indent="0">
               <a:buNone/>
             </a:pPr>
             <a:r>
@@ -7586,7 +7604,7 @@
           <a:bodyPr wrap="square" lIns="0" tIns="0" rIns="0" bIns="0" rtlCol="0" anchor="ctr"/>
           <a:lstStyle/>
           <a:p>
-            <a:pPr indent="0" marL="0">
+            <a:pPr marL="0" indent="0">
               <a:spcAft>
                 <a:spcPts val="800"/>
               </a:spcAft>
@@ -7691,7 +7709,7 @@
           <a:bodyPr wrap="square" lIns="0" tIns="0" rIns="0" bIns="0" rtlCol="0" anchor="ctr"/>
           <a:lstStyle/>
           <a:p>
-            <a:pPr indent="0" marL="0">
+            <a:pPr marL="0" indent="0">
               <a:buNone/>
             </a:pPr>
             <a:r>
@@ -7725,6 +7743,7 @@
         <a:solidFill>
           <a:srgbClr val="FFFFFF"/>
         </a:solidFill>
+        <a:effectLst/>
       </p:bgPr>
     </p:bg>
     <p:spTree>
@@ -7762,11 +7781,11 @@
           <a:bodyPr wrap="square" lIns="0" tIns="0" rIns="0" bIns="0" rtlCol="0" anchor="ctr"/>
           <a:lstStyle/>
           <a:p>
-            <a:pPr indent="0" marL="0">
-              <a:buNone/>
-            </a:pPr>
-            <a:r>
-              <a:rPr lang="en-US" sz="1200" b="1" spc="160" kern="0" dirty="0">
+            <a:pPr marL="0" indent="0">
+              <a:buNone/>
+            </a:pPr>
+            <a:r>
+              <a:rPr lang="en-US" sz="1200" b="1" kern="0" spc="160" dirty="0">
                 <a:solidFill>
                   <a:srgbClr val="6B7280"/>
                 </a:solidFill>
@@ -7801,7 +7820,7 @@
           <a:bodyPr wrap="square" lIns="0" tIns="0" rIns="0" bIns="0" rtlCol="0" anchor="t"/>
           <a:lstStyle/>
           <a:p>
-            <a:pPr indent="0" marL="0">
+            <a:pPr marL="0" indent="0">
               <a:buNone/>
             </a:pPr>
             <a:r>
@@ -7845,6 +7864,13 @@
             <a:prstDash val="solid"/>
           </a:ln>
         </p:spPr>
+        <p:txBody>
+          <a:bodyPr/>
+          <a:lstStyle/>
+          <a:p>
+            <a:endParaRPr lang="en-AU"/>
+          </a:p>
+        </p:txBody>
       </p:sp>
       <p:sp>
         <p:nvSpPr>
@@ -7867,11 +7893,11 @@
           <a:bodyPr wrap="square" lIns="0" tIns="0" rIns="0" bIns="0" rtlCol="0" anchor="ctr"/>
           <a:lstStyle/>
           <a:p>
-            <a:pPr algn="ctr" indent="0" marL="0">
-              <a:buNone/>
-            </a:pPr>
-            <a:r>
-              <a:rPr lang="en-US" sz="1200" b="1" spc="120" kern="0" dirty="0">
+            <a:pPr marL="0" indent="0" algn="ctr">
+              <a:buNone/>
+            </a:pPr>
+            <a:r>
+              <a:rPr lang="en-US" sz="1200" b="1" kern="0" spc="120" dirty="0">
                 <a:solidFill>
                   <a:srgbClr val="FFFFFF"/>
                 </a:solidFill>
@@ -7911,6 +7937,13 @@
             <a:prstDash val="solid"/>
           </a:ln>
         </p:spPr>
+        <p:txBody>
+          <a:bodyPr/>
+          <a:lstStyle/>
+          <a:p>
+            <a:endParaRPr lang="en-AU"/>
+          </a:p>
+        </p:txBody>
       </p:sp>
       <p:sp>
         <p:nvSpPr>
@@ -7933,11 +7966,11 @@
           <a:bodyPr wrap="square" lIns="0" tIns="0" rIns="0" bIns="0" rtlCol="0" anchor="ctr"/>
           <a:lstStyle/>
           <a:p>
-            <a:pPr algn="ctr" indent="0" marL="0">
-              <a:buNone/>
-            </a:pPr>
-            <a:r>
-              <a:rPr lang="en-US" sz="1100" b="1" spc="100" kern="0" dirty="0">
+            <a:pPr marL="0" indent="0" algn="ctr">
+              <a:buNone/>
+            </a:pPr>
+            <a:r>
+              <a:rPr lang="en-US" sz="1100" b="1" kern="0" spc="100" dirty="0">
                 <a:solidFill>
                   <a:srgbClr val="EF4444"/>
                 </a:solidFill>
@@ -7977,13 +8010,20 @@
             <a:prstDash val="solid"/>
           </a:ln>
           <a:effectLst>
-            <a:outerShdw sx="100000" sy="100000" kx="0" ky="0" algn="bl" rotWithShape="0" blurRad="76200" dist="12700" dir="5400000">
+            <a:outerShdw blurRad="76200" dist="12700" dir="5400000" algn="bl" rotWithShape="0">
               <a:srgbClr val="9AA4B2">
                 <a:alpha val="18000"/>
               </a:srgbClr>
             </a:outerShdw>
           </a:effectLst>
         </p:spPr>
+        <p:txBody>
+          <a:bodyPr/>
+          <a:lstStyle/>
+          <a:p>
+            <a:endParaRPr lang="en-AU"/>
+          </a:p>
+        </p:txBody>
       </p:sp>
       <p:sp>
         <p:nvSpPr>
@@ -8006,7 +8046,7 @@
           <a:bodyPr wrap="square" lIns="0" tIns="0" rIns="0" bIns="0" rtlCol="0" anchor="ctr"/>
           <a:lstStyle/>
           <a:p>
-            <a:pPr indent="0" marL="0">
+            <a:pPr marL="0" indent="0">
               <a:buNone/>
             </a:pPr>
             <a:r>
@@ -8018,7 +8058,7 @@
                 <a:ea typeface="Calibri" pitchFamily="34" charset="-122"/>
                 <a:cs typeface="Calibri" pitchFamily="34" charset="-120"/>
               </a:rPr>
-              <a:t>To critique a game against named design criteria — then apply that judgement to your own game as CAT build time begins.</a:t>
+              <a:t>To critique a game against design criteria, then apply that judgement to your own game.</a:t>
             </a:r>
             <a:endParaRPr lang="en-US" sz="2100" dirty="0"/>
           </a:p>
@@ -8050,13 +8090,20 @@
             <a:prstDash val="solid"/>
           </a:ln>
           <a:effectLst>
-            <a:outerShdw sx="100000" sy="100000" kx="0" ky="0" algn="bl" rotWithShape="0" blurRad="76200" dist="12700" dir="5400000">
+            <a:outerShdw blurRad="76200" dist="12700" dir="5400000" algn="bl" rotWithShape="0">
               <a:srgbClr val="9AA4B2">
                 <a:alpha val="18000"/>
               </a:srgbClr>
             </a:outerShdw>
           </a:effectLst>
         </p:spPr>
+        <p:txBody>
+          <a:bodyPr/>
+          <a:lstStyle/>
+          <a:p>
+            <a:endParaRPr lang="en-AU"/>
+          </a:p>
+        </p:txBody>
       </p:sp>
       <p:sp>
         <p:nvSpPr>
@@ -8079,7 +8126,7 @@
           <a:bodyPr wrap="square" lIns="0" tIns="0" rIns="0" bIns="0" rtlCol="0" anchor="ctr"/>
           <a:lstStyle/>
           <a:p>
-            <a:pPr indent="0" marL="0">
+            <a:pPr marL="0" indent="0">
               <a:buNone/>
             </a:pPr>
             <a:r>
@@ -8118,7 +8165,7 @@
           <a:bodyPr wrap="square" lIns="0" tIns="0" rIns="0" bIns="0" rtlCol="0" anchor="ctr"/>
           <a:lstStyle/>
           <a:p>
-            <a:pPr indent="0" marL="0">
+            <a:pPr marL="0" indent="0">
               <a:lnSpc>
                 <a:spcPts val="2300"/>
               </a:lnSpc>
@@ -8138,7 +8185,7 @@
             <a:endParaRPr lang="en-US" sz="1700" dirty="0"/>
           </a:p>
           <a:p>
-            <a:pPr indent="0" marL="0">
+            <a:pPr marL="0" indent="0">
               <a:lnSpc>
                 <a:spcPts val="2300"/>
               </a:lnSpc>
@@ -8147,7 +8194,7 @@
             <a:endParaRPr lang="en-US" sz="1700" dirty="0"/>
           </a:p>
           <a:p>
-            <a:pPr indent="0" marL="0">
+            <a:pPr marL="0" indent="0">
               <a:lnSpc>
                 <a:spcPts val="2300"/>
               </a:lnSpc>
@@ -8194,13 +8241,20 @@
             <a:prstDash val="solid"/>
           </a:ln>
           <a:effectLst>
-            <a:outerShdw sx="100000" sy="100000" kx="0" ky="0" algn="bl" rotWithShape="0" blurRad="76200" dist="12700" dir="5400000">
+            <a:outerShdw blurRad="76200" dist="12700" dir="5400000" algn="bl" rotWithShape="0">
               <a:srgbClr val="9AA4B2">
                 <a:alpha val="18000"/>
               </a:srgbClr>
             </a:outerShdw>
           </a:effectLst>
         </p:spPr>
+        <p:txBody>
+          <a:bodyPr/>
+          <a:lstStyle/>
+          <a:p>
+            <a:endParaRPr lang="en-AU"/>
+          </a:p>
+        </p:txBody>
       </p:sp>
       <p:sp>
         <p:nvSpPr>
@@ -8223,7 +8277,7 @@
           <a:bodyPr wrap="square" lIns="0" tIns="0" rIns="0" bIns="0" rtlCol="0" anchor="ctr"/>
           <a:lstStyle/>
           <a:p>
-            <a:pPr indent="0" marL="0">
+            <a:pPr marL="0" indent="0">
               <a:buNone/>
             </a:pPr>
             <a:r>
@@ -8262,7 +8316,7 @@
           <a:bodyPr wrap="square" lIns="0" tIns="0" rIns="0" bIns="0" rtlCol="0" anchor="ctr"/>
           <a:lstStyle/>
           <a:p>
-            <a:pPr indent="0" marL="0">
+            <a:pPr marL="0" indent="0">
               <a:lnSpc>
                 <a:spcPts val="2300"/>
               </a:lnSpc>
@@ -8282,7 +8336,7 @@
             <a:endParaRPr lang="en-US" sz="1700" dirty="0"/>
           </a:p>
           <a:p>
-            <a:pPr indent="0" marL="0">
+            <a:pPr marL="0" indent="0">
               <a:lnSpc>
                 <a:spcPts val="2300"/>
               </a:lnSpc>
@@ -8291,7 +8345,7 @@
             <a:endParaRPr lang="en-US" sz="1700" dirty="0"/>
           </a:p>
           <a:p>
-            <a:pPr indent="0" marL="0">
+            <a:pPr marL="0" indent="0">
               <a:lnSpc>
                 <a:spcPts val="2300"/>
               </a:lnSpc>
@@ -8338,13 +8392,20 @@
             <a:prstDash val="solid"/>
           </a:ln>
           <a:effectLst>
-            <a:outerShdw sx="100000" sy="100000" kx="0" ky="0" algn="bl" rotWithShape="0" blurRad="76200" dist="12700" dir="5400000">
+            <a:outerShdw blurRad="76200" dist="12700" dir="5400000" algn="bl" rotWithShape="0">
               <a:srgbClr val="9AA4B2">
                 <a:alpha val="18000"/>
               </a:srgbClr>
             </a:outerShdw>
           </a:effectLst>
         </p:spPr>
+        <p:txBody>
+          <a:bodyPr/>
+          <a:lstStyle/>
+          <a:p>
+            <a:endParaRPr lang="en-AU"/>
+          </a:p>
+        </p:txBody>
       </p:sp>
       <p:sp>
         <p:nvSpPr>
@@ -8367,7 +8428,7 @@
           <a:bodyPr wrap="square" lIns="0" tIns="0" rIns="0" bIns="0" rtlCol="0" anchor="ctr"/>
           <a:lstStyle/>
           <a:p>
-            <a:pPr indent="0" marL="0">
+            <a:pPr marL="0" indent="0">
               <a:buNone/>
             </a:pPr>
             <a:r>
@@ -8406,7 +8467,7 @@
           <a:bodyPr wrap="square" lIns="0" tIns="0" rIns="0" bIns="0" rtlCol="0" anchor="ctr"/>
           <a:lstStyle/>
           <a:p>
-            <a:pPr indent="0" marL="0">
+            <a:pPr marL="0" indent="0">
               <a:lnSpc>
                 <a:spcPts val="2300"/>
               </a:lnSpc>
@@ -8426,7 +8487,7 @@
             <a:endParaRPr lang="en-US" sz="1700" dirty="0"/>
           </a:p>
           <a:p>
-            <a:pPr indent="0" marL="0">
+            <a:pPr marL="0" indent="0">
               <a:lnSpc>
                 <a:spcPts val="2300"/>
               </a:lnSpc>
@@ -8435,7 +8496,7 @@
             <a:endParaRPr lang="en-US" sz="1700" dirty="0"/>
           </a:p>
           <a:p>
-            <a:pPr indent="0" marL="0">
+            <a:pPr marL="0" indent="0">
               <a:lnSpc>
                 <a:spcPts val="2300"/>
               </a:lnSpc>
@@ -8477,7 +8538,7 @@
           <a:bodyPr wrap="square" lIns="0" tIns="0" rIns="0" bIns="0" rtlCol="0" anchor="ctr"/>
           <a:lstStyle/>
           <a:p>
-            <a:pPr indent="0" marL="0">
+            <a:pPr marL="0" indent="0">
               <a:buNone/>
             </a:pPr>
             <a:r>
@@ -8511,6 +8572,7 @@
         <a:solidFill>
           <a:srgbClr val="FFFFFF"/>
         </a:solidFill>
+        <a:effectLst/>
       </p:bgPr>
     </p:bg>
     <p:spTree>
@@ -8548,11 +8610,11 @@
           <a:bodyPr wrap="square" lIns="0" tIns="0" rIns="0" bIns="0" rtlCol="0" anchor="ctr"/>
           <a:lstStyle/>
           <a:p>
-            <a:pPr indent="0" marL="0">
-              <a:buNone/>
-            </a:pPr>
-            <a:r>
-              <a:rPr lang="en-US" sz="1200" b="1" spc="160" kern="0" dirty="0">
+            <a:pPr marL="0" indent="0">
+              <a:buNone/>
+            </a:pPr>
+            <a:r>
+              <a:rPr lang="en-US" sz="1200" b="1" kern="0" spc="160" dirty="0">
                 <a:solidFill>
                   <a:srgbClr val="6B7280"/>
                 </a:solidFill>
@@ -8587,7 +8649,7 @@
           <a:bodyPr wrap="square" lIns="0" tIns="0" rIns="0" bIns="0" rtlCol="0" anchor="t"/>
           <a:lstStyle/>
           <a:p>
-            <a:pPr indent="0" marL="0">
+            <a:pPr marL="0" indent="0">
               <a:buNone/>
             </a:pPr>
             <a:r>
@@ -8631,6 +8693,13 @@
             <a:prstDash val="solid"/>
           </a:ln>
         </p:spPr>
+        <p:txBody>
+          <a:bodyPr/>
+          <a:lstStyle/>
+          <a:p>
+            <a:endParaRPr lang="en-AU"/>
+          </a:p>
+        </p:txBody>
       </p:sp>
       <p:sp>
         <p:nvSpPr>
@@ -8653,11 +8722,11 @@
           <a:bodyPr wrap="square" lIns="0" tIns="0" rIns="0" bIns="0" rtlCol="0" anchor="ctr"/>
           <a:lstStyle/>
           <a:p>
-            <a:pPr algn="ctr" indent="0" marL="0">
-              <a:buNone/>
-            </a:pPr>
-            <a:r>
-              <a:rPr lang="en-US" sz="1200" b="1" spc="120" kern="0" dirty="0">
+            <a:pPr marL="0" indent="0" algn="ctr">
+              <a:buNone/>
+            </a:pPr>
+            <a:r>
+              <a:rPr lang="en-US" sz="1200" b="1" kern="0" spc="120" dirty="0">
                 <a:solidFill>
                   <a:srgbClr val="FFFFFF"/>
                 </a:solidFill>
@@ -8697,6 +8766,13 @@
             <a:prstDash val="solid"/>
           </a:ln>
         </p:spPr>
+        <p:txBody>
+          <a:bodyPr/>
+          <a:lstStyle/>
+          <a:p>
+            <a:endParaRPr lang="en-AU"/>
+          </a:p>
+        </p:txBody>
       </p:sp>
       <p:sp>
         <p:nvSpPr>
@@ -8719,11 +8795,11 @@
           <a:bodyPr wrap="square" lIns="0" tIns="0" rIns="0" bIns="0" rtlCol="0" anchor="ctr"/>
           <a:lstStyle/>
           <a:p>
-            <a:pPr algn="ctr" indent="0" marL="0">
-              <a:buNone/>
-            </a:pPr>
-            <a:r>
-              <a:rPr lang="en-US" sz="1100" b="1" spc="100" kern="0" dirty="0">
+            <a:pPr marL="0" indent="0" algn="ctr">
+              <a:buNone/>
+            </a:pPr>
+            <a:r>
+              <a:rPr lang="en-US" sz="1100" b="1" kern="0" spc="100" dirty="0">
                 <a:solidFill>
                   <a:srgbClr val="EF4444"/>
                 </a:solidFill>
@@ -8758,7 +8834,7 @@
           <a:bodyPr wrap="square" lIns="0" tIns="0" rIns="0" bIns="0" rtlCol="0" anchor="ctr"/>
           <a:lstStyle/>
           <a:p>
-            <a:pPr indent="0" marL="0">
+            <a:pPr marL="0" indent="0">
               <a:buNone/>
             </a:pPr>
             <a:r>
@@ -8802,13 +8878,20 @@
             <a:prstDash val="solid"/>
           </a:ln>
           <a:effectLst>
-            <a:outerShdw sx="100000" sy="100000" kx="0" ky="0" algn="bl" rotWithShape="0" blurRad="76200" dist="12700" dir="5400000">
+            <a:outerShdw blurRad="76200" dist="12700" dir="5400000" algn="bl" rotWithShape="0">
               <a:srgbClr val="9AA4B2">
                 <a:alpha val="18000"/>
               </a:srgbClr>
             </a:outerShdw>
           </a:effectLst>
         </p:spPr>
+        <p:txBody>
+          <a:bodyPr/>
+          <a:lstStyle/>
+          <a:p>
+            <a:endParaRPr lang="en-AU"/>
+          </a:p>
+        </p:txBody>
       </p:sp>
       <p:sp>
         <p:nvSpPr>
@@ -8834,6 +8917,13 @@
             <a:prstDash val="solid"/>
           </a:ln>
         </p:spPr>
+        <p:txBody>
+          <a:bodyPr/>
+          <a:lstStyle/>
+          <a:p>
+            <a:endParaRPr lang="en-AU"/>
+          </a:p>
+        </p:txBody>
       </p:sp>
       <p:sp>
         <p:nvSpPr>
@@ -8856,7 +8946,7 @@
           <a:bodyPr wrap="square" lIns="0" tIns="0" rIns="0" bIns="0" rtlCol="0" anchor="ctr"/>
           <a:lstStyle/>
           <a:p>
-            <a:pPr algn="ctr" indent="0" marL="0">
+            <a:pPr marL="0" indent="0" algn="ctr">
               <a:buNone/>
             </a:pPr>
             <a:r>
@@ -8895,7 +8985,7 @@
           <a:bodyPr wrap="square" lIns="0" tIns="0" rIns="0" bIns="0" rtlCol="0" anchor="ctr"/>
           <a:lstStyle/>
           <a:p>
-            <a:pPr indent="0" marL="0">
+            <a:pPr marL="0" indent="0">
               <a:buNone/>
             </a:pPr>
             <a:r>
@@ -8934,7 +9024,7 @@
           <a:bodyPr wrap="square" lIns="0" tIns="0" rIns="0" bIns="0" rtlCol="0" anchor="ctr"/>
           <a:lstStyle/>
           <a:p>
-            <a:pPr indent="0" marL="0">
+            <a:pPr marL="0" indent="0">
               <a:buNone/>
             </a:pPr>
             <a:r>
@@ -8978,13 +9068,20 @@
             <a:prstDash val="solid"/>
           </a:ln>
           <a:effectLst>
-            <a:outerShdw sx="100000" sy="100000" kx="0" ky="0" algn="bl" rotWithShape="0" blurRad="76200" dist="12700" dir="5400000">
+            <a:outerShdw blurRad="76200" dist="12700" dir="5400000" algn="bl" rotWithShape="0">
               <a:srgbClr val="9AA4B2">
                 <a:alpha val="18000"/>
               </a:srgbClr>
             </a:outerShdw>
           </a:effectLst>
         </p:spPr>
+        <p:txBody>
+          <a:bodyPr/>
+          <a:lstStyle/>
+          <a:p>
+            <a:endParaRPr lang="en-AU"/>
+          </a:p>
+        </p:txBody>
       </p:sp>
       <p:sp>
         <p:nvSpPr>
@@ -9010,6 +9107,13 @@
             <a:prstDash val="solid"/>
           </a:ln>
         </p:spPr>
+        <p:txBody>
+          <a:bodyPr/>
+          <a:lstStyle/>
+          <a:p>
+            <a:endParaRPr lang="en-AU"/>
+          </a:p>
+        </p:txBody>
       </p:sp>
       <p:sp>
         <p:nvSpPr>
@@ -9032,7 +9136,7 @@
           <a:bodyPr wrap="square" lIns="0" tIns="0" rIns="0" bIns="0" rtlCol="0" anchor="ctr"/>
           <a:lstStyle/>
           <a:p>
-            <a:pPr algn="ctr" indent="0" marL="0">
+            <a:pPr marL="0" indent="0" algn="ctr">
               <a:buNone/>
             </a:pPr>
             <a:r>
@@ -9071,7 +9175,7 @@
           <a:bodyPr wrap="square" lIns="0" tIns="0" rIns="0" bIns="0" rtlCol="0" anchor="ctr"/>
           <a:lstStyle/>
           <a:p>
-            <a:pPr indent="0" marL="0">
+            <a:pPr marL="0" indent="0">
               <a:buNone/>
             </a:pPr>
             <a:r>
@@ -9110,7 +9214,7 @@
           <a:bodyPr wrap="square" lIns="0" tIns="0" rIns="0" bIns="0" rtlCol="0" anchor="ctr"/>
           <a:lstStyle/>
           <a:p>
-            <a:pPr indent="0" marL="0">
+            <a:pPr marL="0" indent="0">
               <a:buNone/>
             </a:pPr>
             <a:r>
@@ -9154,13 +9258,20 @@
             <a:prstDash val="solid"/>
           </a:ln>
           <a:effectLst>
-            <a:outerShdw sx="100000" sy="100000" kx="0" ky="0" algn="bl" rotWithShape="0" blurRad="76200" dist="12700" dir="5400000">
+            <a:outerShdw blurRad="76200" dist="12700" dir="5400000" algn="bl" rotWithShape="0">
               <a:srgbClr val="9AA4B2">
                 <a:alpha val="18000"/>
               </a:srgbClr>
             </a:outerShdw>
           </a:effectLst>
         </p:spPr>
+        <p:txBody>
+          <a:bodyPr/>
+          <a:lstStyle/>
+          <a:p>
+            <a:endParaRPr lang="en-AU"/>
+          </a:p>
+        </p:txBody>
       </p:sp>
       <p:sp>
         <p:nvSpPr>
@@ -9186,6 +9297,13 @@
             <a:prstDash val="solid"/>
           </a:ln>
         </p:spPr>
+        <p:txBody>
+          <a:bodyPr/>
+          <a:lstStyle/>
+          <a:p>
+            <a:endParaRPr lang="en-AU"/>
+          </a:p>
+        </p:txBody>
       </p:sp>
       <p:sp>
         <p:nvSpPr>
@@ -9208,7 +9326,7 @@
           <a:bodyPr wrap="square" lIns="0" tIns="0" rIns="0" bIns="0" rtlCol="0" anchor="ctr"/>
           <a:lstStyle/>
           <a:p>
-            <a:pPr algn="ctr" indent="0" marL="0">
+            <a:pPr marL="0" indent="0" algn="ctr">
               <a:buNone/>
             </a:pPr>
             <a:r>
@@ -9247,7 +9365,7 @@
           <a:bodyPr wrap="square" lIns="0" tIns="0" rIns="0" bIns="0" rtlCol="0" anchor="ctr"/>
           <a:lstStyle/>
           <a:p>
-            <a:pPr indent="0" marL="0">
+            <a:pPr marL="0" indent="0">
               <a:buNone/>
             </a:pPr>
             <a:r>
@@ -9286,7 +9404,7 @@
           <a:bodyPr wrap="square" lIns="0" tIns="0" rIns="0" bIns="0" rtlCol="0" anchor="ctr"/>
           <a:lstStyle/>
           <a:p>
-            <a:pPr indent="0" marL="0">
+            <a:pPr marL="0" indent="0">
               <a:buNone/>
             </a:pPr>
             <a:r>
@@ -9330,13 +9448,20 @@
             <a:prstDash val="solid"/>
           </a:ln>
           <a:effectLst>
-            <a:outerShdw sx="100000" sy="100000" kx="0" ky="0" algn="bl" rotWithShape="0" blurRad="76200" dist="12700" dir="5400000">
+            <a:outerShdw blurRad="76200" dist="12700" dir="5400000" algn="bl" rotWithShape="0">
               <a:srgbClr val="9AA4B2">
                 <a:alpha val="18000"/>
               </a:srgbClr>
             </a:outerShdw>
           </a:effectLst>
         </p:spPr>
+        <p:txBody>
+          <a:bodyPr/>
+          <a:lstStyle/>
+          <a:p>
+            <a:endParaRPr lang="en-AU"/>
+          </a:p>
+        </p:txBody>
       </p:sp>
       <p:sp>
         <p:nvSpPr>
@@ -9362,6 +9487,13 @@
             <a:prstDash val="solid"/>
           </a:ln>
         </p:spPr>
+        <p:txBody>
+          <a:bodyPr/>
+          <a:lstStyle/>
+          <a:p>
+            <a:endParaRPr lang="en-AU"/>
+          </a:p>
+        </p:txBody>
       </p:sp>
       <p:sp>
         <p:nvSpPr>
@@ -9384,7 +9516,7 @@
           <a:bodyPr wrap="square" lIns="0" tIns="0" rIns="0" bIns="0" rtlCol="0" anchor="ctr"/>
           <a:lstStyle/>
           <a:p>
-            <a:pPr algn="ctr" indent="0" marL="0">
+            <a:pPr marL="0" indent="0" algn="ctr">
               <a:buNone/>
             </a:pPr>
             <a:r>
@@ -9423,7 +9555,7 @@
           <a:bodyPr wrap="square" lIns="0" tIns="0" rIns="0" bIns="0" rtlCol="0" anchor="ctr"/>
           <a:lstStyle/>
           <a:p>
-            <a:pPr indent="0" marL="0">
+            <a:pPr marL="0" indent="0">
               <a:buNone/>
             </a:pPr>
             <a:r>
@@ -9462,7 +9594,7 @@
           <a:bodyPr wrap="square" lIns="0" tIns="0" rIns="0" bIns="0" rtlCol="0" anchor="ctr"/>
           <a:lstStyle/>
           <a:p>
-            <a:pPr indent="0" marL="0">
+            <a:pPr marL="0" indent="0">
               <a:buNone/>
             </a:pPr>
             <a:r>
@@ -9506,6 +9638,13 @@
             <a:prstDash val="solid"/>
           </a:ln>
         </p:spPr>
+        <p:txBody>
+          <a:bodyPr/>
+          <a:lstStyle/>
+          <a:p>
+            <a:endParaRPr lang="en-AU"/>
+          </a:p>
+        </p:txBody>
       </p:sp>
       <p:sp>
         <p:nvSpPr>
@@ -9528,7 +9667,7 @@
           <a:bodyPr wrap="square" lIns="0" tIns="0" rIns="0" bIns="0" rtlCol="0" anchor="ctr"/>
           <a:lstStyle/>
           <a:p>
-            <a:pPr indent="0" marL="0">
+            <a:pPr marL="0" indent="0">
               <a:buNone/>
             </a:pPr>
             <a:r>
@@ -9562,6 +9701,7 @@
         <a:solidFill>
           <a:srgbClr val="FFFFFF"/>
         </a:solidFill>
+        <a:effectLst/>
       </p:bgPr>
     </p:bg>
     <p:spTree>
@@ -9599,11 +9739,11 @@
           <a:bodyPr wrap="square" lIns="0" tIns="0" rIns="0" bIns="0" rtlCol="0" anchor="ctr"/>
           <a:lstStyle/>
           <a:p>
-            <a:pPr indent="0" marL="0">
-              <a:buNone/>
-            </a:pPr>
-            <a:r>
-              <a:rPr lang="en-US" sz="1200" b="1" spc="160" kern="0" dirty="0">
+            <a:pPr marL="0" indent="0">
+              <a:buNone/>
+            </a:pPr>
+            <a:r>
+              <a:rPr lang="en-US" sz="1200" b="1" kern="0" spc="160" dirty="0">
                 <a:solidFill>
                   <a:srgbClr val="6B7280"/>
                 </a:solidFill>
@@ -9638,7 +9778,7 @@
           <a:bodyPr wrap="square" lIns="0" tIns="0" rIns="0" bIns="0" rtlCol="0" anchor="t"/>
           <a:lstStyle/>
           <a:p>
-            <a:pPr indent="0" marL="0">
+            <a:pPr marL="0" indent="0">
               <a:buNone/>
             </a:pPr>
             <a:r>
@@ -9682,6 +9822,13 @@
             <a:prstDash val="solid"/>
           </a:ln>
         </p:spPr>
+        <p:txBody>
+          <a:bodyPr/>
+          <a:lstStyle/>
+          <a:p>
+            <a:endParaRPr lang="en-AU"/>
+          </a:p>
+        </p:txBody>
       </p:sp>
       <p:sp>
         <p:nvSpPr>
@@ -9704,11 +9851,11 @@
           <a:bodyPr wrap="square" lIns="0" tIns="0" rIns="0" bIns="0" rtlCol="0" anchor="ctr"/>
           <a:lstStyle/>
           <a:p>
-            <a:pPr algn="ctr" indent="0" marL="0">
-              <a:buNone/>
-            </a:pPr>
-            <a:r>
-              <a:rPr lang="en-US" sz="1200" b="1" spc="120" kern="0" dirty="0">
+            <a:pPr marL="0" indent="0" algn="ctr">
+              <a:buNone/>
+            </a:pPr>
+            <a:r>
+              <a:rPr lang="en-US" sz="1200" b="1" kern="0" spc="120" dirty="0">
                 <a:solidFill>
                   <a:srgbClr val="FFFFFF"/>
                 </a:solidFill>
@@ -9748,6 +9895,13 @@
             <a:prstDash val="solid"/>
           </a:ln>
         </p:spPr>
+        <p:txBody>
+          <a:bodyPr/>
+          <a:lstStyle/>
+          <a:p>
+            <a:endParaRPr lang="en-AU"/>
+          </a:p>
+        </p:txBody>
       </p:sp>
       <p:sp>
         <p:nvSpPr>
@@ -9770,11 +9924,11 @@
           <a:bodyPr wrap="square" lIns="0" tIns="0" rIns="0" bIns="0" rtlCol="0" anchor="ctr"/>
           <a:lstStyle/>
           <a:p>
-            <a:pPr algn="ctr" indent="0" marL="0">
-              <a:buNone/>
-            </a:pPr>
-            <a:r>
-              <a:rPr lang="en-US" sz="1100" b="1" spc="100" kern="0" dirty="0">
+            <a:pPr marL="0" indent="0" algn="ctr">
+              <a:buNone/>
+            </a:pPr>
+            <a:r>
+              <a:rPr lang="en-US" sz="1100" b="1" kern="0" spc="100" dirty="0">
                 <a:solidFill>
                   <a:srgbClr val="EF4444"/>
                 </a:solidFill>
@@ -9814,13 +9968,20 @@
             <a:prstDash val="solid"/>
           </a:ln>
           <a:effectLst>
-            <a:outerShdw sx="100000" sy="100000" kx="0" ky="0" algn="bl" rotWithShape="0" blurRad="76200" dist="12700" dir="5400000">
+            <a:outerShdw blurRad="76200" dist="12700" dir="5400000" algn="bl" rotWithShape="0">
               <a:srgbClr val="9AA4B2">
                 <a:alpha val="18000"/>
               </a:srgbClr>
             </a:outerShdw>
           </a:effectLst>
         </p:spPr>
+        <p:txBody>
+          <a:bodyPr/>
+          <a:lstStyle/>
+          <a:p>
+            <a:endParaRPr lang="en-AU"/>
+          </a:p>
+        </p:txBody>
       </p:sp>
       <p:sp>
         <p:nvSpPr>
@@ -9843,7 +10004,7 @@
           <a:bodyPr wrap="square" lIns="0" tIns="0" rIns="0" bIns="0" rtlCol="0" anchor="ctr"/>
           <a:lstStyle/>
           <a:p>
-            <a:pPr indent="0" marL="0">
+            <a:pPr marL="0" indent="0">
               <a:buNone/>
             </a:pPr>
             <a:r>
@@ -9882,7 +10043,7 @@
           <a:bodyPr wrap="square" lIns="0" tIns="0" rIns="0" bIns="0" rtlCol="0" anchor="ctr"/>
           <a:lstStyle/>
           <a:p>
-            <a:pPr indent="0" marL="0">
+            <a:pPr marL="0" indent="0">
               <a:lnSpc>
                 <a:spcPts val="2800"/>
               </a:lnSpc>
@@ -9902,7 +10063,7 @@
             <a:endParaRPr lang="en-US" sz="1900" dirty="0"/>
           </a:p>
           <a:p>
-            <a:pPr indent="0" marL="0">
+            <a:pPr marL="0" indent="0">
               <a:lnSpc>
                 <a:spcPts val="2800"/>
               </a:lnSpc>
@@ -9922,7 +10083,7 @@
             <a:endParaRPr lang="en-US" sz="1900" dirty="0"/>
           </a:p>
           <a:p>
-            <a:pPr indent="0" marL="0">
+            <a:pPr marL="0" indent="0">
               <a:lnSpc>
                 <a:spcPts val="2800"/>
               </a:lnSpc>
@@ -9969,13 +10130,20 @@
             <a:prstDash val="solid"/>
           </a:ln>
           <a:effectLst>
-            <a:outerShdw sx="100000" sy="100000" kx="0" ky="0" algn="bl" rotWithShape="0" blurRad="76200" dist="12700" dir="5400000">
+            <a:outerShdw blurRad="76200" dist="12700" dir="5400000" algn="bl" rotWithShape="0">
               <a:srgbClr val="9AA4B2">
                 <a:alpha val="18000"/>
               </a:srgbClr>
             </a:outerShdw>
           </a:effectLst>
         </p:spPr>
+        <p:txBody>
+          <a:bodyPr/>
+          <a:lstStyle/>
+          <a:p>
+            <a:endParaRPr lang="en-AU"/>
+          </a:p>
+        </p:txBody>
       </p:sp>
       <p:sp>
         <p:nvSpPr>
@@ -9998,7 +10166,7 @@
           <a:bodyPr wrap="square" lIns="0" tIns="0" rIns="0" bIns="0" rtlCol="0" anchor="ctr"/>
           <a:lstStyle/>
           <a:p>
-            <a:pPr indent="0" marL="0">
+            <a:pPr marL="0" indent="0">
               <a:buNone/>
             </a:pPr>
             <a:r>
@@ -10037,7 +10205,7 @@
           <a:bodyPr wrap="square" lIns="0" tIns="0" rIns="0" bIns="0" rtlCol="0" anchor="ctr"/>
           <a:lstStyle/>
           <a:p>
-            <a:pPr indent="0" marL="0">
+            <a:pPr marL="0" indent="0">
               <a:lnSpc>
                 <a:spcPts val="2600"/>
               </a:lnSpc>
@@ -10084,13 +10252,20 @@
             <a:prstDash val="solid"/>
           </a:ln>
           <a:effectLst>
-            <a:outerShdw sx="100000" sy="100000" kx="0" ky="0" algn="bl" rotWithShape="0" blurRad="76200" dist="12700" dir="5400000">
+            <a:outerShdw blurRad="76200" dist="12700" dir="5400000" algn="bl" rotWithShape="0">
               <a:srgbClr val="9AA4B2">
                 <a:alpha val="18000"/>
               </a:srgbClr>
             </a:outerShdw>
           </a:effectLst>
         </p:spPr>
+        <p:txBody>
+          <a:bodyPr/>
+          <a:lstStyle/>
+          <a:p>
+            <a:endParaRPr lang="en-AU"/>
+          </a:p>
+        </p:txBody>
       </p:sp>
       <p:sp>
         <p:nvSpPr>
@@ -10113,7 +10288,7 @@
           <a:bodyPr wrap="square" lIns="0" tIns="0" rIns="0" bIns="0" rtlCol="0" anchor="ctr"/>
           <a:lstStyle/>
           <a:p>
-            <a:pPr indent="0" marL="0">
+            <a:pPr marL="0" indent="0">
               <a:buNone/>
             </a:pPr>
             <a:r>
@@ -10152,7 +10327,7 @@
           <a:bodyPr wrap="square" lIns="0" tIns="0" rIns="0" bIns="0" rtlCol="0" anchor="ctr"/>
           <a:lstStyle/>
           <a:p>
-            <a:pPr indent="0" marL="0">
+            <a:pPr marL="0" indent="0">
               <a:buNone/>
             </a:pPr>
             <a:r>
@@ -10191,7 +10366,7 @@
           <a:bodyPr wrap="square" lIns="0" tIns="0" rIns="0" bIns="0" rtlCol="0" anchor="ctr"/>
           <a:lstStyle/>
           <a:p>
-            <a:pPr indent="0" marL="0">
+            <a:pPr marL="0" indent="0">
               <a:buNone/>
             </a:pPr>
             <a:r>
@@ -10235,6 +10410,13 @@
             <a:prstDash val="solid"/>
           </a:ln>
         </p:spPr>
+        <p:txBody>
+          <a:bodyPr/>
+          <a:lstStyle/>
+          <a:p>
+            <a:endParaRPr lang="en-AU"/>
+          </a:p>
+        </p:txBody>
       </p:sp>
       <p:sp>
         <p:nvSpPr>
@@ -10257,7 +10439,7 @@
           <a:bodyPr wrap="square" lIns="0" tIns="0" rIns="0" bIns="0" rtlCol="0" anchor="ctr"/>
           <a:lstStyle/>
           <a:p>
-            <a:pPr indent="0" marL="0">
+            <a:pPr marL="0" indent="0">
               <a:buNone/>
             </a:pPr>
             <a:r>
@@ -10291,6 +10473,7 @@
         <a:solidFill>
           <a:srgbClr val="FFFFFF"/>
         </a:solidFill>
+        <a:effectLst/>
       </p:bgPr>
     </p:bg>
     <p:spTree>
@@ -10328,11 +10511,11 @@
           <a:bodyPr wrap="square" lIns="0" tIns="0" rIns="0" bIns="0" rtlCol="0" anchor="ctr"/>
           <a:lstStyle/>
           <a:p>
-            <a:pPr indent="0" marL="0">
-              <a:buNone/>
-            </a:pPr>
-            <a:r>
-              <a:rPr lang="en-US" sz="1200" b="1" spc="160" kern="0" dirty="0">
+            <a:pPr marL="0" indent="0">
+              <a:buNone/>
+            </a:pPr>
+            <a:r>
+              <a:rPr lang="en-US" sz="1200" b="1" kern="0" spc="160" dirty="0">
                 <a:solidFill>
                   <a:srgbClr val="6B7280"/>
                 </a:solidFill>
@@ -10367,7 +10550,7 @@
           <a:bodyPr wrap="square" lIns="0" tIns="0" rIns="0" bIns="0" rtlCol="0" anchor="t"/>
           <a:lstStyle/>
           <a:p>
-            <a:pPr indent="0" marL="0">
+            <a:pPr marL="0" indent="0">
               <a:buNone/>
             </a:pPr>
             <a:r>
@@ -10411,6 +10594,13 @@
             <a:prstDash val="solid"/>
           </a:ln>
         </p:spPr>
+        <p:txBody>
+          <a:bodyPr/>
+          <a:lstStyle/>
+          <a:p>
+            <a:endParaRPr lang="en-AU"/>
+          </a:p>
+        </p:txBody>
       </p:sp>
       <p:sp>
         <p:nvSpPr>
@@ -10433,11 +10623,11 @@
           <a:bodyPr wrap="square" lIns="0" tIns="0" rIns="0" bIns="0" rtlCol="0" anchor="ctr"/>
           <a:lstStyle/>
           <a:p>
-            <a:pPr algn="ctr" indent="0" marL="0">
-              <a:buNone/>
-            </a:pPr>
-            <a:r>
-              <a:rPr lang="en-US" sz="1200" b="1" spc="120" kern="0" dirty="0">
+            <a:pPr marL="0" indent="0" algn="ctr">
+              <a:buNone/>
+            </a:pPr>
+            <a:r>
+              <a:rPr lang="en-US" sz="1200" b="1" kern="0" spc="120" dirty="0">
                 <a:solidFill>
                   <a:srgbClr val="FFFFFF"/>
                 </a:solidFill>
@@ -10477,6 +10667,13 @@
             <a:prstDash val="solid"/>
           </a:ln>
         </p:spPr>
+        <p:txBody>
+          <a:bodyPr/>
+          <a:lstStyle/>
+          <a:p>
+            <a:endParaRPr lang="en-AU"/>
+          </a:p>
+        </p:txBody>
       </p:sp>
       <p:sp>
         <p:nvSpPr>
@@ -10499,11 +10696,11 @@
           <a:bodyPr wrap="square" lIns="0" tIns="0" rIns="0" bIns="0" rtlCol="0" anchor="ctr"/>
           <a:lstStyle/>
           <a:p>
-            <a:pPr algn="ctr" indent="0" marL="0">
-              <a:buNone/>
-            </a:pPr>
-            <a:r>
-              <a:rPr lang="en-US" sz="1100" b="1" spc="100" kern="0" dirty="0">
+            <a:pPr marL="0" indent="0" algn="ctr">
+              <a:buNone/>
+            </a:pPr>
+            <a:r>
+              <a:rPr lang="en-US" sz="1100" b="1" kern="0" spc="100" dirty="0">
                 <a:solidFill>
                   <a:srgbClr val="10B981"/>
                 </a:solidFill>
@@ -10538,7 +10735,7 @@
           <a:bodyPr wrap="square" lIns="0" tIns="0" rIns="0" bIns="0" rtlCol="0" anchor="ctr"/>
           <a:lstStyle/>
           <a:p>
-            <a:pPr indent="0" marL="0">
+            <a:pPr marL="0" indent="0">
               <a:buNone/>
             </a:pPr>
             <a:r>
@@ -10582,13 +10779,20 @@
             <a:prstDash val="solid"/>
           </a:ln>
           <a:effectLst>
-            <a:outerShdw sx="100000" sy="100000" kx="0" ky="0" algn="bl" rotWithShape="0" blurRad="76200" dist="12700" dir="5400000">
+            <a:outerShdw blurRad="76200" dist="12700" dir="5400000" algn="bl" rotWithShape="0">
               <a:srgbClr val="9AA4B2">
                 <a:alpha val="18000"/>
               </a:srgbClr>
             </a:outerShdw>
           </a:effectLst>
         </p:spPr>
+        <p:txBody>
+          <a:bodyPr/>
+          <a:lstStyle/>
+          <a:p>
+            <a:endParaRPr lang="en-AU"/>
+          </a:p>
+        </p:txBody>
       </p:sp>
       <p:sp>
         <p:nvSpPr>
@@ -10611,7 +10815,7 @@
           <a:bodyPr wrap="square" lIns="0" tIns="0" rIns="0" bIns="0" rtlCol="0" anchor="ctr"/>
           <a:lstStyle/>
           <a:p>
-            <a:pPr indent="0" marL="0">
+            <a:pPr marL="0" indent="0">
               <a:buNone/>
             </a:pPr>
             <a:r>
@@ -10650,7 +10854,7 @@
           <a:bodyPr wrap="square" lIns="0" tIns="0" rIns="0" bIns="0" rtlCol="0" anchor="ctr"/>
           <a:lstStyle/>
           <a:p>
-            <a:pPr indent="0" marL="0">
+            <a:pPr marL="0" indent="0">
               <a:buNone/>
             </a:pPr>
             <a:r>
@@ -10694,13 +10898,20 @@
             <a:prstDash val="solid"/>
           </a:ln>
           <a:effectLst>
-            <a:outerShdw sx="100000" sy="100000" kx="0" ky="0" algn="bl" rotWithShape="0" blurRad="76200" dist="12700" dir="5400000">
+            <a:outerShdw blurRad="76200" dist="12700" dir="5400000" algn="bl" rotWithShape="0">
               <a:srgbClr val="9AA4B2">
                 <a:alpha val="18000"/>
               </a:srgbClr>
             </a:outerShdw>
           </a:effectLst>
         </p:spPr>
+        <p:txBody>
+          <a:bodyPr/>
+          <a:lstStyle/>
+          <a:p>
+            <a:endParaRPr lang="en-AU"/>
+          </a:p>
+        </p:txBody>
       </p:sp>
       <p:sp>
         <p:nvSpPr>
@@ -10723,7 +10934,7 @@
           <a:bodyPr wrap="square" lIns="0" tIns="0" rIns="0" bIns="0" rtlCol="0" anchor="ctr"/>
           <a:lstStyle/>
           <a:p>
-            <a:pPr indent="0" marL="0">
+            <a:pPr marL="0" indent="0">
               <a:buNone/>
             </a:pPr>
             <a:r>
@@ -10762,7 +10973,7 @@
           <a:bodyPr wrap="square" lIns="0" tIns="0" rIns="0" bIns="0" rtlCol="0" anchor="ctr"/>
           <a:lstStyle/>
           <a:p>
-            <a:pPr indent="0" marL="0">
+            <a:pPr marL="0" indent="0">
               <a:buNone/>
             </a:pPr>
             <a:r>
@@ -10806,13 +11017,20 @@
             <a:prstDash val="solid"/>
           </a:ln>
           <a:effectLst>
-            <a:outerShdw sx="100000" sy="100000" kx="0" ky="0" algn="bl" rotWithShape="0" blurRad="76200" dist="12700" dir="5400000">
+            <a:outerShdw blurRad="76200" dist="12700" dir="5400000" algn="bl" rotWithShape="0">
               <a:srgbClr val="9AA4B2">
                 <a:alpha val="18000"/>
               </a:srgbClr>
             </a:outerShdw>
           </a:effectLst>
         </p:spPr>
+        <p:txBody>
+          <a:bodyPr/>
+          <a:lstStyle/>
+          <a:p>
+            <a:endParaRPr lang="en-AU"/>
+          </a:p>
+        </p:txBody>
       </p:sp>
       <p:sp>
         <p:nvSpPr>
@@ -10835,7 +11053,7 @@
           <a:bodyPr wrap="square" lIns="0" tIns="0" rIns="0" bIns="0" rtlCol="0" anchor="ctr"/>
           <a:lstStyle/>
           <a:p>
-            <a:pPr indent="0" marL="0">
+            <a:pPr marL="0" indent="0">
               <a:buNone/>
             </a:pPr>
             <a:r>
@@ -10874,7 +11092,7 @@
           <a:bodyPr wrap="square" lIns="0" tIns="0" rIns="0" bIns="0" rtlCol="0" anchor="ctr"/>
           <a:lstStyle/>
           <a:p>
-            <a:pPr indent="0" marL="0">
+            <a:pPr marL="0" indent="0">
               <a:buNone/>
             </a:pPr>
             <a:r>
@@ -10918,13 +11136,20 @@
             <a:prstDash val="solid"/>
           </a:ln>
           <a:effectLst>
-            <a:outerShdw sx="100000" sy="100000" kx="0" ky="0" algn="bl" rotWithShape="0" blurRad="76200" dist="12700" dir="5400000">
+            <a:outerShdw blurRad="76200" dist="12700" dir="5400000" algn="bl" rotWithShape="0">
               <a:srgbClr val="9AA4B2">
                 <a:alpha val="18000"/>
               </a:srgbClr>
             </a:outerShdw>
           </a:effectLst>
         </p:spPr>
+        <p:txBody>
+          <a:bodyPr/>
+          <a:lstStyle/>
+          <a:p>
+            <a:endParaRPr lang="en-AU"/>
+          </a:p>
+        </p:txBody>
       </p:sp>
       <p:sp>
         <p:nvSpPr>
@@ -10947,7 +11172,7 @@
           <a:bodyPr wrap="square" lIns="0" tIns="0" rIns="0" bIns="0" rtlCol="0" anchor="ctr"/>
           <a:lstStyle/>
           <a:p>
-            <a:pPr indent="0" marL="0">
+            <a:pPr marL="0" indent="0">
               <a:buNone/>
             </a:pPr>
             <a:r>
@@ -10986,7 +11211,7 @@
           <a:bodyPr wrap="square" lIns="0" tIns="0" rIns="0" bIns="0" rtlCol="0" anchor="ctr"/>
           <a:lstStyle/>
           <a:p>
-            <a:pPr indent="0" marL="0">
+            <a:pPr marL="0" indent="0">
               <a:buNone/>
             </a:pPr>
             <a:r>
@@ -11025,7 +11250,7 @@
           <a:bodyPr wrap="square" lIns="0" tIns="0" rIns="0" bIns="0" rtlCol="0" anchor="ctr"/>
           <a:lstStyle/>
           <a:p>
-            <a:pPr indent="0" marL="0">
+            <a:pPr marL="0" indent="0">
               <a:buNone/>
             </a:pPr>
             <a:r>
@@ -11059,6 +11284,7 @@
         <a:solidFill>
           <a:srgbClr val="FFFFFF"/>
         </a:solidFill>
+        <a:effectLst/>
       </p:bgPr>
     </p:bg>
     <p:spTree>
@@ -11096,11 +11322,11 @@
           <a:bodyPr wrap="square" lIns="0" tIns="0" rIns="0" bIns="0" rtlCol="0" anchor="ctr"/>
           <a:lstStyle/>
           <a:p>
-            <a:pPr indent="0" marL="0">
-              <a:buNone/>
-            </a:pPr>
-            <a:r>
-              <a:rPr lang="en-US" sz="1200" b="1" spc="160" kern="0" dirty="0">
+            <a:pPr marL="0" indent="0">
+              <a:buNone/>
+            </a:pPr>
+            <a:r>
+              <a:rPr lang="en-US" sz="1200" b="1" kern="0" spc="160" dirty="0">
                 <a:solidFill>
                   <a:srgbClr val="6B7280"/>
                 </a:solidFill>
@@ -11135,7 +11361,7 @@
           <a:bodyPr wrap="square" lIns="0" tIns="0" rIns="0" bIns="0" rtlCol="0" anchor="t"/>
           <a:lstStyle/>
           <a:p>
-            <a:pPr indent="0" marL="0">
+            <a:pPr marL="0" indent="0">
               <a:buNone/>
             </a:pPr>
             <a:r>
@@ -11179,6 +11405,13 @@
             <a:prstDash val="solid"/>
           </a:ln>
         </p:spPr>
+        <p:txBody>
+          <a:bodyPr/>
+          <a:lstStyle/>
+          <a:p>
+            <a:endParaRPr lang="en-AU"/>
+          </a:p>
+        </p:txBody>
       </p:sp>
       <p:sp>
         <p:nvSpPr>
@@ -11201,11 +11434,11 @@
           <a:bodyPr wrap="square" lIns="0" tIns="0" rIns="0" bIns="0" rtlCol="0" anchor="ctr"/>
           <a:lstStyle/>
           <a:p>
-            <a:pPr algn="ctr" indent="0" marL="0">
-              <a:buNone/>
-            </a:pPr>
-            <a:r>
-              <a:rPr lang="en-US" sz="1200" b="1" spc="120" kern="0" dirty="0">
+            <a:pPr marL="0" indent="0" algn="ctr">
+              <a:buNone/>
+            </a:pPr>
+            <a:r>
+              <a:rPr lang="en-US" sz="1200" b="1" kern="0" spc="120" dirty="0">
                 <a:solidFill>
                   <a:srgbClr val="FFFFFF"/>
                 </a:solidFill>
@@ -11245,6 +11478,13 @@
             <a:prstDash val="solid"/>
           </a:ln>
         </p:spPr>
+        <p:txBody>
+          <a:bodyPr/>
+          <a:lstStyle/>
+          <a:p>
+            <a:endParaRPr lang="en-AU"/>
+          </a:p>
+        </p:txBody>
       </p:sp>
       <p:sp>
         <p:nvSpPr>
@@ -11267,11 +11507,11 @@
           <a:bodyPr wrap="square" lIns="0" tIns="0" rIns="0" bIns="0" rtlCol="0" anchor="ctr"/>
           <a:lstStyle/>
           <a:p>
-            <a:pPr algn="ctr" indent="0" marL="0">
-              <a:buNone/>
-            </a:pPr>
-            <a:r>
-              <a:rPr lang="en-US" sz="1100" b="1" spc="100" kern="0" dirty="0">
+            <a:pPr marL="0" indent="0" algn="ctr">
+              <a:buNone/>
+            </a:pPr>
+            <a:r>
+              <a:rPr lang="en-US" sz="1100" b="1" kern="0" spc="100" dirty="0">
                 <a:solidFill>
                   <a:srgbClr val="10B981"/>
                 </a:solidFill>
@@ -11311,13 +11551,20 @@
             <a:prstDash val="solid"/>
           </a:ln>
           <a:effectLst>
-            <a:outerShdw sx="100000" sy="100000" kx="0" ky="0" algn="bl" rotWithShape="0" blurRad="76200" dist="12700" dir="5400000">
+            <a:outerShdw blurRad="76200" dist="12700" dir="5400000" algn="bl" rotWithShape="0">
               <a:srgbClr val="9AA4B2">
                 <a:alpha val="18000"/>
               </a:srgbClr>
             </a:outerShdw>
           </a:effectLst>
         </p:spPr>
+        <p:txBody>
+          <a:bodyPr/>
+          <a:lstStyle/>
+          <a:p>
+            <a:endParaRPr lang="en-AU"/>
+          </a:p>
+        </p:txBody>
       </p:sp>
       <p:sp>
         <p:nvSpPr>
@@ -11340,7 +11587,7 @@
           <a:bodyPr wrap="square" lIns="0" tIns="0" rIns="0" bIns="0" rtlCol="0" anchor="ctr"/>
           <a:lstStyle/>
           <a:p>
-            <a:pPr indent="0" marL="0">
+            <a:pPr marL="0" indent="0">
               <a:buNone/>
             </a:pPr>
             <a:r>
@@ -11384,13 +11631,20 @@
             <a:prstDash val="solid"/>
           </a:ln>
           <a:effectLst>
-            <a:outerShdw sx="100000" sy="100000" kx="0" ky="0" algn="bl" rotWithShape="0" blurRad="76200" dist="12700" dir="5400000">
+            <a:outerShdw blurRad="76200" dist="12700" dir="5400000" algn="bl" rotWithShape="0">
               <a:srgbClr val="9AA4B2">
                 <a:alpha val="18000"/>
               </a:srgbClr>
             </a:outerShdw>
           </a:effectLst>
         </p:spPr>
+        <p:txBody>
+          <a:bodyPr/>
+          <a:lstStyle/>
+          <a:p>
+            <a:endParaRPr lang="en-AU"/>
+          </a:p>
+        </p:txBody>
       </p:sp>
       <p:sp>
         <p:nvSpPr>
@@ -11416,6 +11670,13 @@
             <a:prstDash val="solid"/>
           </a:ln>
         </p:spPr>
+        <p:txBody>
+          <a:bodyPr/>
+          <a:lstStyle/>
+          <a:p>
+            <a:endParaRPr lang="en-AU"/>
+          </a:p>
+        </p:txBody>
       </p:sp>
       <p:sp>
         <p:nvSpPr>
@@ -11438,7 +11699,7 @@
           <a:bodyPr wrap="square" lIns="0" tIns="0" rIns="0" bIns="0" rtlCol="0" anchor="ctr"/>
           <a:lstStyle/>
           <a:p>
-            <a:pPr algn="ctr" indent="0" marL="0">
+            <a:pPr marL="0" indent="0" algn="ctr">
               <a:buNone/>
             </a:pPr>
             <a:r>
@@ -11477,7 +11738,7 @@
           <a:bodyPr wrap="square" lIns="0" tIns="0" rIns="0" bIns="0" rtlCol="0" anchor="ctr"/>
           <a:lstStyle/>
           <a:p>
-            <a:pPr indent="0" marL="0">
+            <a:pPr marL="0" indent="0">
               <a:buNone/>
             </a:pPr>
             <a:r>
@@ -11516,7 +11777,7 @@
           <a:bodyPr wrap="square" lIns="0" tIns="0" rIns="0" bIns="0" rtlCol="0" anchor="ctr"/>
           <a:lstStyle/>
           <a:p>
-            <a:pPr indent="0" marL="0">
+            <a:pPr marL="0" indent="0">
               <a:buNone/>
             </a:pPr>
             <a:r>
@@ -11560,13 +11821,20 @@
             <a:prstDash val="solid"/>
           </a:ln>
           <a:effectLst>
-            <a:outerShdw sx="100000" sy="100000" kx="0" ky="0" algn="bl" rotWithShape="0" blurRad="76200" dist="12700" dir="5400000">
+            <a:outerShdw blurRad="76200" dist="12700" dir="5400000" algn="bl" rotWithShape="0">
               <a:srgbClr val="9AA4B2">
                 <a:alpha val="18000"/>
               </a:srgbClr>
             </a:outerShdw>
           </a:effectLst>
         </p:spPr>
+        <p:txBody>
+          <a:bodyPr/>
+          <a:lstStyle/>
+          <a:p>
+            <a:endParaRPr lang="en-AU"/>
+          </a:p>
+        </p:txBody>
       </p:sp>
       <p:sp>
         <p:nvSpPr>
@@ -11592,6 +11860,13 @@
             <a:prstDash val="solid"/>
           </a:ln>
         </p:spPr>
+        <p:txBody>
+          <a:bodyPr/>
+          <a:lstStyle/>
+          <a:p>
+            <a:endParaRPr lang="en-AU"/>
+          </a:p>
+        </p:txBody>
       </p:sp>
       <p:sp>
         <p:nvSpPr>
@@ -11614,7 +11889,7 @@
           <a:bodyPr wrap="square" lIns="0" tIns="0" rIns="0" bIns="0" rtlCol="0" anchor="ctr"/>
           <a:lstStyle/>
           <a:p>
-            <a:pPr algn="ctr" indent="0" marL="0">
+            <a:pPr marL="0" indent="0" algn="ctr">
               <a:buNone/>
             </a:pPr>
             <a:r>
@@ -11653,7 +11928,7 @@
           <a:bodyPr wrap="square" lIns="0" tIns="0" rIns="0" bIns="0" rtlCol="0" anchor="ctr"/>
           <a:lstStyle/>
           <a:p>
-            <a:pPr indent="0" marL="0">
+            <a:pPr marL="0" indent="0">
               <a:buNone/>
             </a:pPr>
             <a:r>
@@ -11692,7 +11967,7 @@
           <a:bodyPr wrap="square" lIns="0" tIns="0" rIns="0" bIns="0" rtlCol="0" anchor="ctr"/>
           <a:lstStyle/>
           <a:p>
-            <a:pPr indent="0" marL="0">
+            <a:pPr marL="0" indent="0">
               <a:buNone/>
             </a:pPr>
             <a:r>
@@ -11736,13 +12011,20 @@
             <a:prstDash val="solid"/>
           </a:ln>
           <a:effectLst>
-            <a:outerShdw sx="100000" sy="100000" kx="0" ky="0" algn="bl" rotWithShape="0" blurRad="76200" dist="12700" dir="5400000">
+            <a:outerShdw blurRad="76200" dist="12700" dir="5400000" algn="bl" rotWithShape="0">
               <a:srgbClr val="9AA4B2">
                 <a:alpha val="18000"/>
               </a:srgbClr>
             </a:outerShdw>
           </a:effectLst>
         </p:spPr>
+        <p:txBody>
+          <a:bodyPr/>
+          <a:lstStyle/>
+          <a:p>
+            <a:endParaRPr lang="en-AU"/>
+          </a:p>
+        </p:txBody>
       </p:sp>
       <p:sp>
         <p:nvSpPr>
@@ -11768,6 +12050,13 @@
             <a:prstDash val="solid"/>
           </a:ln>
         </p:spPr>
+        <p:txBody>
+          <a:bodyPr/>
+          <a:lstStyle/>
+          <a:p>
+            <a:endParaRPr lang="en-AU"/>
+          </a:p>
+        </p:txBody>
       </p:sp>
       <p:sp>
         <p:nvSpPr>
@@ -11790,7 +12079,7 @@
           <a:bodyPr wrap="square" lIns="0" tIns="0" rIns="0" bIns="0" rtlCol="0" anchor="ctr"/>
           <a:lstStyle/>
           <a:p>
-            <a:pPr algn="ctr" indent="0" marL="0">
+            <a:pPr marL="0" indent="0" algn="ctr">
               <a:buNone/>
             </a:pPr>
             <a:r>
@@ -11829,7 +12118,7 @@
           <a:bodyPr wrap="square" lIns="0" tIns="0" rIns="0" bIns="0" rtlCol="0" anchor="ctr"/>
           <a:lstStyle/>
           <a:p>
-            <a:pPr indent="0" marL="0">
+            <a:pPr marL="0" indent="0">
               <a:buNone/>
             </a:pPr>
             <a:r>
@@ -11868,7 +12157,7 @@
           <a:bodyPr wrap="square" lIns="0" tIns="0" rIns="0" bIns="0" rtlCol="0" anchor="ctr"/>
           <a:lstStyle/>
           <a:p>
-            <a:pPr indent="0" marL="0">
+            <a:pPr marL="0" indent="0">
               <a:buNone/>
             </a:pPr>
             <a:r>
@@ -11912,13 +12201,20 @@
             <a:prstDash val="solid"/>
           </a:ln>
           <a:effectLst>
-            <a:outerShdw sx="100000" sy="100000" kx="0" ky="0" algn="bl" rotWithShape="0" blurRad="76200" dist="12700" dir="5400000">
+            <a:outerShdw blurRad="76200" dist="12700" dir="5400000" algn="bl" rotWithShape="0">
               <a:srgbClr val="9AA4B2">
                 <a:alpha val="18000"/>
               </a:srgbClr>
             </a:outerShdw>
           </a:effectLst>
         </p:spPr>
+        <p:txBody>
+          <a:bodyPr/>
+          <a:lstStyle/>
+          <a:p>
+            <a:endParaRPr lang="en-AU"/>
+          </a:p>
+        </p:txBody>
       </p:sp>
       <p:sp>
         <p:nvSpPr>
@@ -11944,6 +12240,13 @@
             <a:prstDash val="solid"/>
           </a:ln>
         </p:spPr>
+        <p:txBody>
+          <a:bodyPr/>
+          <a:lstStyle/>
+          <a:p>
+            <a:endParaRPr lang="en-AU"/>
+          </a:p>
+        </p:txBody>
       </p:sp>
       <p:sp>
         <p:nvSpPr>
@@ -11966,7 +12269,7 @@
           <a:bodyPr wrap="square" lIns="0" tIns="0" rIns="0" bIns="0" rtlCol="0" anchor="ctr"/>
           <a:lstStyle/>
           <a:p>
-            <a:pPr algn="ctr" indent="0" marL="0">
+            <a:pPr marL="0" indent="0" algn="ctr">
               <a:buNone/>
             </a:pPr>
             <a:r>
@@ -12005,7 +12308,7 @@
           <a:bodyPr wrap="square" lIns="0" tIns="0" rIns="0" bIns="0" rtlCol="0" anchor="ctr"/>
           <a:lstStyle/>
           <a:p>
-            <a:pPr indent="0" marL="0">
+            <a:pPr marL="0" indent="0">
               <a:buNone/>
             </a:pPr>
             <a:r>
@@ -12044,7 +12347,7 @@
           <a:bodyPr wrap="square" lIns="0" tIns="0" rIns="0" bIns="0" rtlCol="0" anchor="ctr"/>
           <a:lstStyle/>
           <a:p>
-            <a:pPr indent="0" marL="0">
+            <a:pPr marL="0" indent="0">
               <a:buNone/>
             </a:pPr>
             <a:r>
@@ -12088,6 +12391,13 @@
             <a:prstDash val="solid"/>
           </a:ln>
         </p:spPr>
+        <p:txBody>
+          <a:bodyPr/>
+          <a:lstStyle/>
+          <a:p>
+            <a:endParaRPr lang="en-AU"/>
+          </a:p>
+        </p:txBody>
       </p:sp>
       <p:sp>
         <p:nvSpPr>
@@ -12110,7 +12420,7 @@
           <a:bodyPr wrap="square" lIns="0" tIns="0" rIns="0" bIns="0" rtlCol="0" anchor="ctr"/>
           <a:lstStyle/>
           <a:p>
-            <a:pPr indent="0" marL="0">
+            <a:pPr marL="0" indent="0">
               <a:buNone/>
             </a:pPr>
             <a:r>
@@ -12144,6 +12454,7 @@
         <a:solidFill>
           <a:srgbClr val="FFFFFF"/>
         </a:solidFill>
+        <a:effectLst/>
       </p:bgPr>
     </p:bg>
     <p:spTree>
@@ -12181,11 +12492,11 @@
           <a:bodyPr wrap="square" lIns="0" tIns="0" rIns="0" bIns="0" rtlCol="0" anchor="ctr"/>
           <a:lstStyle/>
           <a:p>
-            <a:pPr indent="0" marL="0">
-              <a:buNone/>
-            </a:pPr>
-            <a:r>
-              <a:rPr lang="en-US" sz="1200" b="1" spc="160" kern="0" dirty="0">
+            <a:pPr marL="0" indent="0">
+              <a:buNone/>
+            </a:pPr>
+            <a:r>
+              <a:rPr lang="en-US" sz="1200" b="1" kern="0" spc="160" dirty="0">
                 <a:solidFill>
                   <a:srgbClr val="6B7280"/>
                 </a:solidFill>
@@ -12220,7 +12531,7 @@
           <a:bodyPr wrap="square" lIns="0" tIns="0" rIns="0" bIns="0" rtlCol="0" anchor="t"/>
           <a:lstStyle/>
           <a:p>
-            <a:pPr indent="0" marL="0">
+            <a:pPr marL="0" indent="0">
               <a:buNone/>
             </a:pPr>
             <a:r>
@@ -12264,6 +12575,13 @@
             <a:prstDash val="solid"/>
           </a:ln>
         </p:spPr>
+        <p:txBody>
+          <a:bodyPr/>
+          <a:lstStyle/>
+          <a:p>
+            <a:endParaRPr lang="en-AU"/>
+          </a:p>
+        </p:txBody>
       </p:sp>
       <p:sp>
         <p:nvSpPr>
@@ -12286,11 +12604,11 @@
           <a:bodyPr wrap="square" lIns="0" tIns="0" rIns="0" bIns="0" rtlCol="0" anchor="ctr"/>
           <a:lstStyle/>
           <a:p>
-            <a:pPr algn="ctr" indent="0" marL="0">
-              <a:buNone/>
-            </a:pPr>
-            <a:r>
-              <a:rPr lang="en-US" sz="1200" b="1" spc="120" kern="0" dirty="0">
+            <a:pPr marL="0" indent="0" algn="ctr">
+              <a:buNone/>
+            </a:pPr>
+            <a:r>
+              <a:rPr lang="en-US" sz="1200" b="1" kern="0" spc="120" dirty="0">
                 <a:solidFill>
                   <a:srgbClr val="FFFFFF"/>
                 </a:solidFill>
@@ -12330,6 +12648,13 @@
             <a:prstDash val="solid"/>
           </a:ln>
         </p:spPr>
+        <p:txBody>
+          <a:bodyPr/>
+          <a:lstStyle/>
+          <a:p>
+            <a:endParaRPr lang="en-AU"/>
+          </a:p>
+        </p:txBody>
       </p:sp>
       <p:sp>
         <p:nvSpPr>
@@ -12352,11 +12677,11 @@
           <a:bodyPr wrap="square" lIns="0" tIns="0" rIns="0" bIns="0" rtlCol="0" anchor="ctr"/>
           <a:lstStyle/>
           <a:p>
-            <a:pPr algn="ctr" indent="0" marL="0">
-              <a:buNone/>
-            </a:pPr>
-            <a:r>
-              <a:rPr lang="en-US" sz="1100" b="1" spc="100" kern="0" dirty="0">
+            <a:pPr marL="0" indent="0" algn="ctr">
+              <a:buNone/>
+            </a:pPr>
+            <a:r>
+              <a:rPr lang="en-US" sz="1100" b="1" kern="0" spc="100" dirty="0">
                 <a:solidFill>
                   <a:srgbClr val="10B981"/>
                 </a:solidFill>
@@ -12391,7 +12716,7 @@
           <a:bodyPr wrap="square" lIns="0" tIns="0" rIns="0" bIns="0" rtlCol="0" anchor="ctr"/>
           <a:lstStyle/>
           <a:p>
-            <a:pPr indent="0" marL="0">
+            <a:pPr marL="0" indent="0">
               <a:buNone/>
             </a:pPr>
             <a:r>
@@ -12435,13 +12760,20 @@
             <a:prstDash val="solid"/>
           </a:ln>
           <a:effectLst>
-            <a:outerShdw sx="100000" sy="100000" kx="0" ky="0" algn="bl" rotWithShape="0" blurRad="76200" dist="12700" dir="5400000">
+            <a:outerShdw blurRad="76200" dist="12700" dir="5400000" algn="bl" rotWithShape="0">
               <a:srgbClr val="9AA4B2">
                 <a:alpha val="18000"/>
               </a:srgbClr>
             </a:outerShdw>
           </a:effectLst>
         </p:spPr>
+        <p:txBody>
+          <a:bodyPr/>
+          <a:lstStyle/>
+          <a:p>
+            <a:endParaRPr lang="en-AU"/>
+          </a:p>
+        </p:txBody>
       </p:sp>
       <p:sp>
         <p:nvSpPr>
@@ -12464,7 +12796,7 @@
           <a:bodyPr wrap="square" lIns="0" tIns="0" rIns="0" bIns="0" rtlCol="0" anchor="ctr"/>
           <a:lstStyle/>
           <a:p>
-            <a:pPr indent="0" marL="0">
+            <a:pPr marL="0" indent="0">
               <a:buNone/>
             </a:pPr>
             <a:r>
@@ -12614,13 +12946,20 @@
             <a:prstDash val="solid"/>
           </a:ln>
           <a:effectLst>
-            <a:outerShdw sx="100000" sy="100000" kx="0" ky="0" algn="bl" rotWithShape="0" blurRad="76200" dist="12700" dir="5400000">
+            <a:outerShdw blurRad="76200" dist="12700" dir="5400000" algn="bl" rotWithShape="0">
               <a:srgbClr val="9AA4B2">
                 <a:alpha val="18000"/>
               </a:srgbClr>
             </a:outerShdw>
           </a:effectLst>
         </p:spPr>
+        <p:txBody>
+          <a:bodyPr/>
+          <a:lstStyle/>
+          <a:p>
+            <a:endParaRPr lang="en-AU"/>
+          </a:p>
+        </p:txBody>
       </p:sp>
       <p:sp>
         <p:nvSpPr>
@@ -12643,7 +12982,7 @@
           <a:bodyPr wrap="square" lIns="0" tIns="0" rIns="0" bIns="0" rtlCol="0" anchor="ctr"/>
           <a:lstStyle/>
           <a:p>
-            <a:pPr indent="0" marL="0">
+            <a:pPr marL="0" indent="0">
               <a:buNone/>
             </a:pPr>
             <a:r>
@@ -12793,13 +13132,20 @@
             <a:prstDash val="solid"/>
           </a:ln>
           <a:effectLst>
-            <a:outerShdw sx="100000" sy="100000" kx="0" ky="0" algn="bl" rotWithShape="0" blurRad="76200" dist="12700" dir="5400000">
+            <a:outerShdw blurRad="76200" dist="12700" dir="5400000" algn="bl" rotWithShape="0">
               <a:srgbClr val="9AA4B2">
                 <a:alpha val="18000"/>
               </a:srgbClr>
             </a:outerShdw>
           </a:effectLst>
         </p:spPr>
+        <p:txBody>
+          <a:bodyPr/>
+          <a:lstStyle/>
+          <a:p>
+            <a:endParaRPr lang="en-AU"/>
+          </a:p>
+        </p:txBody>
       </p:sp>
       <p:sp>
         <p:nvSpPr>
@@ -12822,7 +13168,7 @@
           <a:bodyPr wrap="square" lIns="0" tIns="0" rIns="0" bIns="0" rtlCol="0" anchor="ctr"/>
           <a:lstStyle/>
           <a:p>
-            <a:pPr indent="0" marL="0">
+            <a:pPr marL="0" indent="0">
               <a:lnSpc>
                 <a:spcPts val="2500"/>
               </a:lnSpc>
@@ -12859,6 +13205,7 @@
         <a:solidFill>
           <a:srgbClr val="FFFFFF"/>
         </a:solidFill>
+        <a:effectLst/>
       </p:bgPr>
     </p:bg>
     <p:spTree>
@@ -12896,11 +13243,11 @@
           <a:bodyPr wrap="square" lIns="0" tIns="0" rIns="0" bIns="0" rtlCol="0" anchor="ctr"/>
           <a:lstStyle/>
           <a:p>
-            <a:pPr indent="0" marL="0">
-              <a:buNone/>
-            </a:pPr>
-            <a:r>
-              <a:rPr lang="en-US" sz="1200" b="1" spc="160" kern="0" dirty="0">
+            <a:pPr marL="0" indent="0">
+              <a:buNone/>
+            </a:pPr>
+            <a:r>
+              <a:rPr lang="en-US" sz="1200" b="1" kern="0" spc="160" dirty="0">
                 <a:solidFill>
                   <a:srgbClr val="6B7280"/>
                 </a:solidFill>
@@ -12935,7 +13282,7 @@
           <a:bodyPr wrap="square" lIns="0" tIns="0" rIns="0" bIns="0" rtlCol="0" anchor="t"/>
           <a:lstStyle/>
           <a:p>
-            <a:pPr indent="0" marL="0">
+            <a:pPr marL="0" indent="0">
               <a:buNone/>
             </a:pPr>
             <a:r>
@@ -12979,6 +13326,13 @@
             <a:prstDash val="solid"/>
           </a:ln>
         </p:spPr>
+        <p:txBody>
+          <a:bodyPr/>
+          <a:lstStyle/>
+          <a:p>
+            <a:endParaRPr lang="en-AU"/>
+          </a:p>
+        </p:txBody>
       </p:sp>
       <p:sp>
         <p:nvSpPr>
@@ -13001,11 +13355,11 @@
           <a:bodyPr wrap="square" lIns="0" tIns="0" rIns="0" bIns="0" rtlCol="0" anchor="ctr"/>
           <a:lstStyle/>
           <a:p>
-            <a:pPr algn="ctr" indent="0" marL="0">
-              <a:buNone/>
-            </a:pPr>
-            <a:r>
-              <a:rPr lang="en-US" sz="1200" b="1" spc="120" kern="0" dirty="0">
+            <a:pPr marL="0" indent="0" algn="ctr">
+              <a:buNone/>
+            </a:pPr>
+            <a:r>
+              <a:rPr lang="en-US" sz="1200" b="1" kern="0" spc="120" dirty="0">
                 <a:solidFill>
                   <a:srgbClr val="FFFFFF"/>
                 </a:solidFill>
@@ -13045,6 +13399,13 @@
             <a:prstDash val="solid"/>
           </a:ln>
         </p:spPr>
+        <p:txBody>
+          <a:bodyPr/>
+          <a:lstStyle/>
+          <a:p>
+            <a:endParaRPr lang="en-AU"/>
+          </a:p>
+        </p:txBody>
       </p:sp>
       <p:sp>
         <p:nvSpPr>
@@ -13067,11 +13428,11 @@
           <a:bodyPr wrap="square" lIns="0" tIns="0" rIns="0" bIns="0" rtlCol="0" anchor="ctr"/>
           <a:lstStyle/>
           <a:p>
-            <a:pPr algn="ctr" indent="0" marL="0">
-              <a:buNone/>
-            </a:pPr>
-            <a:r>
-              <a:rPr lang="en-US" sz="1100" b="1" spc="100" kern="0" dirty="0">
+            <a:pPr marL="0" indent="0" algn="ctr">
+              <a:buNone/>
+            </a:pPr>
+            <a:r>
+              <a:rPr lang="en-US" sz="1100" b="1" kern="0" spc="100" dirty="0">
                 <a:solidFill>
                   <a:srgbClr val="EF4444"/>
                 </a:solidFill>
@@ -13111,13 +13472,20 @@
             <a:prstDash val="solid"/>
           </a:ln>
           <a:effectLst>
-            <a:outerShdw sx="100000" sy="100000" kx="0" ky="0" algn="bl" rotWithShape="0" blurRad="76200" dist="12700" dir="5400000">
+            <a:outerShdw blurRad="76200" dist="12700" dir="5400000" algn="bl" rotWithShape="0">
               <a:srgbClr val="9AA4B2">
                 <a:alpha val="18000"/>
               </a:srgbClr>
             </a:outerShdw>
           </a:effectLst>
         </p:spPr>
+        <p:txBody>
+          <a:bodyPr/>
+          <a:lstStyle/>
+          <a:p>
+            <a:endParaRPr lang="en-AU"/>
+          </a:p>
+        </p:txBody>
       </p:sp>
       <p:sp>
         <p:nvSpPr>
@@ -13140,7 +13508,7 @@
           <a:bodyPr wrap="square" lIns="0" tIns="0" rIns="0" bIns="0" rtlCol="0" anchor="ctr"/>
           <a:lstStyle/>
           <a:p>
-            <a:pPr indent="0" marL="0">
+            <a:pPr marL="0" indent="0">
               <a:buNone/>
             </a:pPr>
             <a:r>
@@ -13179,7 +13547,7 @@
           <a:bodyPr wrap="square" lIns="0" tIns="0" rIns="0" bIns="0" rtlCol="0" anchor="ctr"/>
           <a:lstStyle/>
           <a:p>
-            <a:pPr indent="0" marL="0">
+            <a:pPr marL="0" indent="0">
               <a:lnSpc>
                 <a:spcPts val="3000"/>
               </a:lnSpc>
@@ -13199,7 +13567,7 @@
             <a:endParaRPr lang="en-US" sz="2100" dirty="0"/>
           </a:p>
           <a:p>
-            <a:pPr indent="0" marL="0">
+            <a:pPr marL="0" indent="0">
               <a:lnSpc>
                 <a:spcPts val="3000"/>
               </a:lnSpc>
@@ -13219,7 +13587,7 @@
             <a:endParaRPr lang="en-US" sz="2100" dirty="0"/>
           </a:p>
           <a:p>
-            <a:pPr indent="0" marL="0">
+            <a:pPr marL="0" indent="0">
               <a:lnSpc>
                 <a:spcPts val="3000"/>
               </a:lnSpc>
@@ -13261,7 +13629,7 @@
           <a:bodyPr wrap="square" lIns="0" tIns="0" rIns="0" bIns="0" rtlCol="0" anchor="ctr"/>
           <a:lstStyle/>
           <a:p>
-            <a:pPr indent="0" marL="0">
+            <a:pPr marL="0" indent="0">
               <a:buNone/>
             </a:pPr>
             <a:r>
@@ -13580,4 +13948,319 @@
     </a:ext>
   </a:extLst>
 </a:theme>
+</file>
+
+<file path=ppt/theme/theme2.xml><?xml version="1.0" encoding="utf-8"?>
+<a:theme xmlns:a="http://schemas.openxmlformats.org/drawingml/2006/main" name="Office Theme">
+  <a:themeElements>
+    <a:clrScheme name="Office">
+      <a:dk1>
+        <a:sysClr val="windowText" lastClr="000000"/>
+      </a:dk1>
+      <a:lt1>
+        <a:sysClr val="window" lastClr="FFFFFF"/>
+      </a:lt1>
+      <a:dk2>
+        <a:srgbClr val="0E2841"/>
+      </a:dk2>
+      <a:lt2>
+        <a:srgbClr val="E8E8E8"/>
+      </a:lt2>
+      <a:accent1>
+        <a:srgbClr val="156082"/>
+      </a:accent1>
+      <a:accent2>
+        <a:srgbClr val="E97132"/>
+      </a:accent2>
+      <a:accent3>
+        <a:srgbClr val="196B24"/>
+      </a:accent3>
+      <a:accent4>
+        <a:srgbClr val="0F9ED5"/>
+      </a:accent4>
+      <a:accent5>
+        <a:srgbClr val="A02B93"/>
+      </a:accent5>
+      <a:accent6>
+        <a:srgbClr val="4EA72E"/>
+      </a:accent6>
+      <a:hlink>
+        <a:srgbClr val="467886"/>
+      </a:hlink>
+      <a:folHlink>
+        <a:srgbClr val="96607D"/>
+      </a:folHlink>
+    </a:clrScheme>
+    <a:fontScheme name="Office">
+      <a:majorFont>
+        <a:latin typeface="Aptos Display" panose="02110004020202020204"/>
+        <a:ea typeface=""/>
+        <a:cs typeface=""/>
+        <a:font script="Jpan" typeface="游ゴシック Light"/>
+        <a:font script="Hang" typeface="맑은 고딕"/>
+        <a:font script="Hans" typeface="等线 Light"/>
+        <a:font script="Hant" typeface="新細明體"/>
+        <a:font script="Arab" typeface="Times New Roman"/>
+        <a:font script="Hebr" typeface="Times New Roman"/>
+        <a:font script="Thai" typeface="Angsana New"/>
+        <a:font script="Ethi" typeface="Nyala"/>
+        <a:font script="Beng" typeface="Vrinda"/>
+        <a:font script="Gujr" typeface="Shruti"/>
+        <a:font script="Khmr" typeface="MoolBoran"/>
+        <a:font script="Knda" typeface="Tunga"/>
+        <a:font script="Guru" typeface="Raavi"/>
+        <a:font script="Cans" typeface="Euphemia"/>
+        <a:font script="Cher" typeface="Plantagenet Cherokee"/>
+        <a:font script="Yiii" typeface="Microsoft Yi Baiti"/>
+        <a:font script="Tibt" typeface="Microsoft Himalaya"/>
+        <a:font script="Thaa" typeface="MV Boli"/>
+        <a:font script="Deva" typeface="Mangal"/>
+        <a:font script="Telu" typeface="Gautami"/>
+        <a:font script="Taml" typeface="Latha"/>
+        <a:font script="Syrc" typeface="Estrangelo Edessa"/>
+        <a:font script="Orya" typeface="Kalinga"/>
+        <a:font script="Mlym" typeface="Kartika"/>
+        <a:font script="Laoo" typeface="DokChampa"/>
+        <a:font script="Sinh" typeface="Iskoola Pota"/>
+        <a:font script="Mong" typeface="Mongolian Baiti"/>
+        <a:font script="Viet" typeface="Times New Roman"/>
+        <a:font script="Uigh" typeface="Microsoft Uighur"/>
+        <a:font script="Geor" typeface="Sylfaen"/>
+        <a:font script="Armn" typeface="Arial"/>
+        <a:font script="Bugi" typeface="Leelawadee UI"/>
+        <a:font script="Bopo" typeface="Microsoft JhengHei"/>
+        <a:font script="Java" typeface="Javanese Text"/>
+        <a:font script="Lisu" typeface="Segoe UI"/>
+        <a:font script="Mymr" typeface="Myanmar Text"/>
+        <a:font script="Nkoo" typeface="Ebrima"/>
+        <a:font script="Olck" typeface="Nirmala UI"/>
+        <a:font script="Osma" typeface="Ebrima"/>
+        <a:font script="Phag" typeface="Phagspa"/>
+        <a:font script="Syrn" typeface="Estrangelo Edessa"/>
+        <a:font script="Syrj" typeface="Estrangelo Edessa"/>
+        <a:font script="Syre" typeface="Estrangelo Edessa"/>
+        <a:font script="Sora" typeface="Nirmala UI"/>
+        <a:font script="Tale" typeface="Microsoft Tai Le"/>
+        <a:font script="Talu" typeface="Microsoft New Tai Lue"/>
+        <a:font script="Tfng" typeface="Ebrima"/>
+      </a:majorFont>
+      <a:minorFont>
+        <a:latin typeface="Aptos" panose="02110004020202020204"/>
+        <a:ea typeface=""/>
+        <a:cs typeface=""/>
+        <a:font script="Jpan" typeface="游ゴシック"/>
+        <a:font script="Hang" typeface="맑은 고딕"/>
+        <a:font script="Hans" typeface="等线"/>
+        <a:font script="Hant" typeface="新細明體"/>
+        <a:font script="Arab" typeface="Arial"/>
+        <a:font script="Hebr" typeface="Arial"/>
+        <a:font script="Thai" typeface="Cordia New"/>
+        <a:font script="Ethi" typeface="Nyala"/>
+        <a:font script="Beng" typeface="Vrinda"/>
+        <a:font script="Gujr" typeface="Shruti"/>
+        <a:font script="Khmr" typeface="DaunPenh"/>
+        <a:font script="Knda" typeface="Tunga"/>
+        <a:font script="Guru" typeface="Raavi"/>
+        <a:font script="Cans" typeface="Euphemia"/>
+        <a:font script="Cher" typeface="Plantagenet Cherokee"/>
+        <a:font script="Yiii" typeface="Microsoft Yi Baiti"/>
+        <a:font script="Tibt" typeface="Microsoft Himalaya"/>
+        <a:font script="Thaa" typeface="MV Boli"/>
+        <a:font script="Deva" typeface="Mangal"/>
+        <a:font script="Telu" typeface="Gautami"/>
+        <a:font script="Taml" typeface="Latha"/>
+        <a:font script="Syrc" typeface="Estrangelo Edessa"/>
+        <a:font script="Orya" typeface="Kalinga"/>
+        <a:font script="Mlym" typeface="Kartika"/>
+        <a:font script="Laoo" typeface="DokChampa"/>
+        <a:font script="Sinh" typeface="Iskoola Pota"/>
+        <a:font script="Mong" typeface="Mongolian Baiti"/>
+        <a:font script="Viet" typeface="Arial"/>
+        <a:font script="Uigh" typeface="Microsoft Uighur"/>
+        <a:font script="Geor" typeface="Sylfaen"/>
+        <a:font script="Armn" typeface="Arial"/>
+        <a:font script="Bugi" typeface="Leelawadee UI"/>
+        <a:font script="Bopo" typeface="Microsoft JhengHei"/>
+        <a:font script="Java" typeface="Javanese Text"/>
+        <a:font script="Lisu" typeface="Segoe UI"/>
+        <a:font script="Mymr" typeface="Myanmar Text"/>
+        <a:font script="Nkoo" typeface="Ebrima"/>
+        <a:font script="Olck" typeface="Nirmala UI"/>
+        <a:font script="Osma" typeface="Ebrima"/>
+        <a:font script="Phag" typeface="Phagspa"/>
+        <a:font script="Syrn" typeface="Estrangelo Edessa"/>
+        <a:font script="Syrj" typeface="Estrangelo Edessa"/>
+        <a:font script="Syre" typeface="Estrangelo Edessa"/>
+        <a:font script="Sora" typeface="Nirmala UI"/>
+        <a:font script="Tale" typeface="Microsoft Tai Le"/>
+        <a:font script="Talu" typeface="Microsoft New Tai Lue"/>
+        <a:font script="Tfng" typeface="Ebrima"/>
+      </a:minorFont>
+    </a:fontScheme>
+    <a:fmtScheme name="Office">
+      <a:fillStyleLst>
+        <a:solidFill>
+          <a:schemeClr val="phClr"/>
+        </a:solidFill>
+        <a:gradFill rotWithShape="1">
+          <a:gsLst>
+            <a:gs pos="0">
+              <a:schemeClr val="phClr">
+                <a:lumMod val="110000"/>
+                <a:satMod val="105000"/>
+                <a:tint val="67000"/>
+              </a:schemeClr>
+            </a:gs>
+            <a:gs pos="50000">
+              <a:schemeClr val="phClr">
+                <a:lumMod val="105000"/>
+                <a:satMod val="103000"/>
+                <a:tint val="73000"/>
+              </a:schemeClr>
+            </a:gs>
+            <a:gs pos="100000">
+              <a:schemeClr val="phClr">
+                <a:lumMod val="105000"/>
+                <a:satMod val="109000"/>
+                <a:tint val="81000"/>
+              </a:schemeClr>
+            </a:gs>
+          </a:gsLst>
+          <a:lin ang="5400000" scaled="0"/>
+        </a:gradFill>
+        <a:gradFill rotWithShape="1">
+          <a:gsLst>
+            <a:gs pos="0">
+              <a:schemeClr val="phClr">
+                <a:satMod val="103000"/>
+                <a:lumMod val="102000"/>
+                <a:tint val="94000"/>
+              </a:schemeClr>
+            </a:gs>
+            <a:gs pos="50000">
+              <a:schemeClr val="phClr">
+                <a:satMod val="110000"/>
+                <a:lumMod val="100000"/>
+                <a:shade val="100000"/>
+              </a:schemeClr>
+            </a:gs>
+            <a:gs pos="100000">
+              <a:schemeClr val="phClr">
+                <a:lumMod val="99000"/>
+                <a:satMod val="120000"/>
+                <a:shade val="78000"/>
+              </a:schemeClr>
+            </a:gs>
+          </a:gsLst>
+          <a:lin ang="5400000" scaled="0"/>
+        </a:gradFill>
+      </a:fillStyleLst>
+      <a:lnStyleLst>
+        <a:ln w="12700" cap="flat" cmpd="sng" algn="ctr">
+          <a:solidFill>
+            <a:schemeClr val="phClr"/>
+          </a:solidFill>
+          <a:prstDash val="solid"/>
+          <a:miter lim="800000"/>
+        </a:ln>
+        <a:ln w="19050" cap="flat" cmpd="sng" algn="ctr">
+          <a:solidFill>
+            <a:schemeClr val="phClr"/>
+          </a:solidFill>
+          <a:prstDash val="solid"/>
+          <a:miter lim="800000"/>
+        </a:ln>
+        <a:ln w="25400" cap="flat" cmpd="sng" algn="ctr">
+          <a:solidFill>
+            <a:schemeClr val="phClr"/>
+          </a:solidFill>
+          <a:prstDash val="solid"/>
+          <a:miter lim="800000"/>
+        </a:ln>
+      </a:lnStyleLst>
+      <a:effectStyleLst>
+        <a:effectStyle>
+          <a:effectLst/>
+        </a:effectStyle>
+        <a:effectStyle>
+          <a:effectLst/>
+        </a:effectStyle>
+        <a:effectStyle>
+          <a:effectLst>
+            <a:outerShdw blurRad="57150" dist="19050" dir="5400000" algn="ctr" rotWithShape="0">
+              <a:srgbClr val="000000">
+                <a:alpha val="63000"/>
+              </a:srgbClr>
+            </a:outerShdw>
+          </a:effectLst>
+        </a:effectStyle>
+      </a:effectStyleLst>
+      <a:bgFillStyleLst>
+        <a:solidFill>
+          <a:schemeClr val="phClr"/>
+        </a:solidFill>
+        <a:solidFill>
+          <a:schemeClr val="phClr">
+            <a:tint val="95000"/>
+            <a:satMod val="170000"/>
+          </a:schemeClr>
+        </a:solidFill>
+        <a:gradFill rotWithShape="1">
+          <a:gsLst>
+            <a:gs pos="0">
+              <a:schemeClr val="phClr">
+                <a:tint val="93000"/>
+                <a:satMod val="150000"/>
+                <a:shade val="98000"/>
+                <a:lumMod val="102000"/>
+              </a:schemeClr>
+            </a:gs>
+            <a:gs pos="50000">
+              <a:schemeClr val="phClr">
+                <a:tint val="98000"/>
+                <a:satMod val="130000"/>
+                <a:shade val="90000"/>
+                <a:lumMod val="103000"/>
+              </a:schemeClr>
+            </a:gs>
+            <a:gs pos="100000">
+              <a:schemeClr val="phClr">
+                <a:shade val="63000"/>
+                <a:satMod val="120000"/>
+              </a:schemeClr>
+            </a:gs>
+          </a:gsLst>
+          <a:lin ang="5400000" scaled="0"/>
+        </a:gradFill>
+      </a:bgFillStyleLst>
+    </a:fmtScheme>
+  </a:themeElements>
+  <a:objectDefaults>
+    <a:lnDef>
+      <a:spPr/>
+      <a:bodyPr/>
+      <a:lstStyle/>
+      <a:style>
+        <a:lnRef idx="2">
+          <a:schemeClr val="accent1"/>
+        </a:lnRef>
+        <a:fillRef idx="0">
+          <a:schemeClr val="accent1"/>
+        </a:fillRef>
+        <a:effectRef idx="1">
+          <a:schemeClr val="accent1"/>
+        </a:effectRef>
+        <a:fontRef idx="minor">
+          <a:schemeClr val="tx1"/>
+        </a:fontRef>
+      </a:style>
+    </a:lnDef>
+  </a:objectDefaults>
+  <a:extraClrSchemeLst/>
+  <a:extLst>
+    <a:ext uri="{05A4C25C-085E-4340-85A3-A5531E510DB2}">
+      <thm15:themeFamily xmlns:thm15="http://schemas.microsoft.com/office/thememl/2012/main" name="Office Theme" id="{2E142A2C-CD16-42D6-873A-C26D2A0506FA}" vid="{1BDDFF52-6CD6-40A5-AB3C-68EB2F1E4D0A}"/>
+    </a:ext>
+  </a:extLst>
+</a:theme>
 </file>
</xml_diff>